<commit_message>
Refocus on simple message: drop repo/QR brag from deck, remove advanced budget artifacts
</commit_message>
<xml_diff>
--- a/deck/workshop.pptx
+++ b/deck/workshop.pptx
@@ -3338,7 +3338,7 @@
                 <a:ea typeface="Calibri" pitchFamily="34" charset="-122"/>
                 <a:cs typeface="Calibri" pitchFamily="34" charset="-120"/>
               </a:rPr>
-              <a:t>Claude Code session built this entire workshop - these slides, all four apps, and the repo you'll get the link to.</a:t>
+              <a:t>Claude Code session built this whole workshop - these slides and all four apps. No template. No help. Just conversation.</a:t>
             </a:r>
             <a:endParaRPr lang="en-US" sz="2400" dirty="0"/>
           </a:p>
@@ -3640,7 +3640,7 @@
                 <a:ea typeface="Calibri" pitchFamily="34" charset="-122"/>
                 <a:cs typeface="Calibri" pitchFamily="34" charset="-120"/>
               </a:rPr>
-              <a:t>Everything's here - take it home</a:t>
+              <a:t>Your turn</a:t>
             </a:r>
             <a:endParaRPr lang="en-US" sz="5000" dirty="0"/>
           </a:p>
@@ -3679,13 +3679,13 @@
             <a:r>
               <a:rPr lang="en-US" sz="2800" dirty="0">
                 <a:solidFill>
-                  <a:srgbClr val="000000"/>
-                </a:solidFill>
-                <a:latin typeface="Calibri" pitchFamily="34" charset="0"/>
-                <a:ea typeface="Calibri" pitchFamily="34" charset="-122"/>
-                <a:cs typeface="Calibri" pitchFamily="34" charset="-120"/>
-              </a:rPr>
-              <a:t>Slides, all four apps, and the how-to cheat-sheets.</a:t>
+                  <a:srgbClr val="0070C0"/>
+                </a:solidFill>
+                <a:latin typeface="Calibri" pitchFamily="34" charset="0"/>
+                <a:ea typeface="Calibri" pitchFamily="34" charset="-122"/>
+                <a:cs typeface="Calibri" pitchFamily="34" charset="-120"/>
+              </a:rPr>
+              <a:t>Open Claude Code. Describe the thing you wish existed.</a:t>
             </a:r>
             <a:endParaRPr lang="en-US" sz="2800" dirty="0"/>
           </a:p>
@@ -3702,13 +3702,13 @@
             <a:r>
               <a:rPr lang="en-US" sz="2800" dirty="0">
                 <a:solidFill>
-                  <a:srgbClr val="800000"/>
-                </a:solidFill>
-                <a:latin typeface="Calibri" pitchFamily="34" charset="0"/>
-                <a:ea typeface="Calibri" pitchFamily="34" charset="-122"/>
-                <a:cs typeface="Calibri" pitchFamily="34" charset="-120"/>
-              </a:rPr>
-              <a:t>[ Repo QR - top right ]</a:t>
+                  <a:srgbClr val="000000"/>
+                </a:solidFill>
+                <a:latin typeface="Calibri" pitchFamily="34" charset="0"/>
+                <a:ea typeface="Calibri" pitchFamily="34" charset="-122"/>
+                <a:cs typeface="Calibri" pitchFamily="34" charset="-120"/>
+              </a:rPr>
+              <a:t>You just watched me do it - no code, no template.</a:t>
             </a:r>
             <a:endParaRPr lang="en-US" sz="2800" dirty="0"/>
           </a:p>
@@ -3743,7 +3743,7 @@
                 <a:ea typeface="Calibri" pitchFamily="34" charset="-122"/>
                 <a:cs typeface="Calibri" pitchFamily="34" charset="-120"/>
               </a:rPr>
-              <a:t>Now go build something you wished existed.</a:t>
+              <a:t>Go build something you wished existed.</a:t>
             </a:r>
             <a:endParaRPr lang="en-US" sz="2800" dirty="0"/>
           </a:p>

</xml_diff>

<commit_message>
Restyle workshop deck to minimalist 'simple' look
Rewrite theme.js: white space, Avenir Next, small gray uppercase
micro-labels with a short teal rule, bold black titles, a faint
watermark word on the cover, and a single muted-teal accent (drops the
UChicago footer/phoenix and the blue/green/maroon semantic palette;
emphasis -> teal, punchlines -> black bold, labels -> gray). Add
kickers and a cover watermark in build.js.
</commit_message>
<xml_diff>
--- a/deck/workshop.pptx
+++ b/deck/workshop.pptx
@@ -2325,66 +2325,55 @@
           <a:chExt cx="0" cy="0"/>
         </a:xfrm>
       </p:grpSpPr>
-      <p:pic>
-        <p:nvPicPr>
-          <p:cNvPr id="2" name="Image 0" descr="/Users/batuhangundogdu/Claude Code Workshop/deck/assets/uchicago-footer.png">    </p:cNvPr>
-          <p:cNvPicPr>
-            <a:picLocks noChangeAspect="1"/>
-          </p:cNvPicPr>
-          <p:nvPr/>
-        </p:nvPicPr>
-        <p:blipFill>
-          <a:blip r:embed="rId1"/>
-          <a:stretch>
-            <a:fillRect/>
-          </a:stretch>
-        </p:blipFill>
-        <p:spPr>
-          <a:xfrm>
-            <a:off x="539496" y="6382512"/>
-            <a:ext cx="2843784" cy="475488"/>
-          </a:xfrm>
-          <a:prstGeom prst="rect">
-            <a:avLst/>
-          </a:prstGeom>
-        </p:spPr>
-      </p:pic>
-      <p:pic>
-        <p:nvPicPr>
-          <p:cNvPr id="3" name="Image 1" descr="/Users/batuhangundogdu/Claude Code Workshop/deck/assets/phoenix.png">    </p:cNvPr>
-          <p:cNvPicPr>
-            <a:picLocks noChangeAspect="1"/>
-          </p:cNvPicPr>
-          <p:nvPr/>
-        </p:nvPicPr>
-        <p:blipFill>
-          <a:blip r:embed="rId2">
-            <a:alphaModFix amt="40000"/>
-          </a:blip>
-          <a:stretch>
-            <a:fillRect/>
-          </a:stretch>
-        </p:blipFill>
-        <p:spPr>
-          <a:xfrm>
-            <a:off x="8311896" y="749808"/>
-            <a:ext cx="5769864" cy="5047488"/>
-          </a:xfrm>
-          <a:prstGeom prst="rect">
-            <a:avLst/>
-          </a:prstGeom>
-        </p:spPr>
-      </p:pic>
-      <p:sp>
-        <p:nvSpPr>
-          <p:cNvPr id="4" name="Text 0"/>
-          <p:cNvSpPr/>
-          <p:nvPr/>
-        </p:nvSpPr>
-        <p:spPr>
-          <a:xfrm>
-            <a:off x="914400" y="1197864"/>
-            <a:ext cx="7607808" cy="2386584"/>
+      <p:sp>
+        <p:nvSpPr>
+          <p:cNvPr id="2" name="Text 0"/>
+          <p:cNvSpPr/>
+          <p:nvPr/>
+        </p:nvSpPr>
+        <p:spPr>
+          <a:xfrm>
+            <a:off x="-365760" y="1280160"/>
+            <a:ext cx="12920472" cy="4206240"/>
+          </a:xfrm>
+          <a:prstGeom prst="rect">
+            <a:avLst/>
+          </a:prstGeom>
+          <a:noFill/>
+          <a:ln/>
+        </p:spPr>
+        <p:txBody>
+          <a:bodyPr wrap="square" lIns="0" tIns="0" rIns="0" bIns="0" rtlCol="0" anchor="ctr"/>
+          <a:lstStyle/>
+          <a:p>
+            <a:pPr algn="l" indent="0" marL="0">
+              <a:buNone/>
+            </a:pPr>
+            <a:r>
+              <a:rPr lang="en-US" sz="21000" b="1" dirty="0">
+                <a:solidFill>
+                  <a:srgbClr val="F1F2F1"/>
+                </a:solidFill>
+                <a:latin typeface="Avenir Next" pitchFamily="34" charset="0"/>
+                <a:ea typeface="Avenir Next" pitchFamily="34" charset="-122"/>
+                <a:cs typeface="Avenir Next" pitchFamily="34" charset="-120"/>
+              </a:rPr>
+              <a:t>talk</a:t>
+            </a:r>
+            <a:endParaRPr lang="en-US" sz="21000" dirty="0"/>
+          </a:p>
+        </p:txBody>
+      </p:sp>
+      <p:sp>
+        <p:nvSpPr>
+          <p:cNvPr id="3" name="Text 1"/>
+          <p:cNvSpPr/>
+          <p:nvPr/>
+        </p:nvSpPr>
+        <p:spPr>
+          <a:xfrm>
+            <a:off x="822960" y="2331720"/>
+            <a:ext cx="10543032" cy="1828800"/>
           </a:xfrm>
           <a:prstGeom prst="rect">
             <a:avLst/>
@@ -2403,30 +2392,50 @@
               <a:buNone/>
             </a:pPr>
             <a:r>
-              <a:rPr lang="en-US" sz="6000" b="1" dirty="0">
-                <a:solidFill>
-                  <a:srgbClr val="000000"/>
-                </a:solidFill>
-                <a:latin typeface="Calibri" pitchFamily="34" charset="0"/>
-                <a:ea typeface="Calibri" pitchFamily="34" charset="-122"/>
-                <a:cs typeface="Calibri" pitchFamily="34" charset="-120"/>
+              <a:rPr lang="en-US" sz="5400" b="1" dirty="0">
+                <a:solidFill>
+                  <a:srgbClr val="111111"/>
+                </a:solidFill>
+                <a:latin typeface="Avenir Next" pitchFamily="34" charset="0"/>
+                <a:ea typeface="Avenir Next" pitchFamily="34" charset="-122"/>
+                <a:cs typeface="Avenir Next" pitchFamily="34" charset="-120"/>
               </a:rPr>
               <a:t>Talk to Your Computer</a:t>
             </a:r>
-            <a:endParaRPr lang="en-US" sz="6000" dirty="0"/>
-          </a:p>
-        </p:txBody>
-      </p:sp>
-      <p:sp>
-        <p:nvSpPr>
-          <p:cNvPr id="5" name="Text 1"/>
-          <p:cNvSpPr/>
-          <p:nvPr/>
-        </p:nvSpPr>
-        <p:spPr>
-          <a:xfrm>
-            <a:off x="950976" y="3685032"/>
-            <a:ext cx="5550408" cy="621792"/>
+            <a:endParaRPr lang="en-US" sz="5400" dirty="0"/>
+          </a:p>
+        </p:txBody>
+      </p:sp>
+      <p:sp>
+        <p:nvSpPr>
+          <p:cNvPr id="4" name="Shape 2"/>
+          <p:cNvSpPr/>
+          <p:nvPr/>
+        </p:nvSpPr>
+        <p:spPr>
+          <a:xfrm>
+            <a:off x="822960" y="4224528"/>
+            <a:ext cx="914400" cy="41148"/>
+          </a:xfrm>
+          <a:prstGeom prst="rect">
+            <a:avLst/>
+          </a:prstGeom>
+          <a:solidFill>
+            <a:srgbClr val="2E7A72"/>
+          </a:solidFill>
+          <a:ln/>
+        </p:spPr>
+      </p:sp>
+      <p:sp>
+        <p:nvSpPr>
+          <p:cNvPr id="5" name="Text 3"/>
+          <p:cNvSpPr/>
+          <p:nvPr/>
+        </p:nvSpPr>
+        <p:spPr>
+          <a:xfrm>
+            <a:off x="822960" y="4389120"/>
+            <a:ext cx="10543032" cy="548640"/>
           </a:xfrm>
           <a:prstGeom prst="rect">
             <a:avLst/>
@@ -2442,30 +2451,30 @@
               <a:buNone/>
             </a:pPr>
             <a:r>
-              <a:rPr lang="en-US" sz="2000" dirty="0">
-                <a:solidFill>
-                  <a:srgbClr val="1F4E79"/>
-                </a:solidFill>
-                <a:latin typeface="Calibri" pitchFamily="34" charset="0"/>
-                <a:ea typeface="Calibri" pitchFamily="34" charset="-122"/>
-                <a:cs typeface="Calibri" pitchFamily="34" charset="-120"/>
-              </a:rPr>
-              <a:t>Claude Code for everyday work  ·  UChicago × Anthropic  ·  Batuhan Gundogdu</a:t>
-            </a:r>
-            <a:endParaRPr lang="en-US" sz="2000" dirty="0"/>
-          </a:p>
-        </p:txBody>
-      </p:sp>
-      <p:sp>
-        <p:nvSpPr>
-          <p:cNvPr id="6" name="Text 2"/>
-          <p:cNvSpPr/>
-          <p:nvPr/>
-        </p:nvSpPr>
-        <p:spPr>
-          <a:xfrm>
-            <a:off x="2743200" y="4937760"/>
-            <a:ext cx="4572000" cy="822960"/>
+              <a:rPr lang="en-US" sz="1400" spc="150" kern="0" dirty="0">
+                <a:solidFill>
+                  <a:srgbClr val="9A9A9A"/>
+                </a:solidFill>
+                <a:latin typeface="Avenir Next" pitchFamily="34" charset="0"/>
+                <a:ea typeface="Avenir Next" pitchFamily="34" charset="-122"/>
+                <a:cs typeface="Avenir Next" pitchFamily="34" charset="-120"/>
+              </a:rPr>
+              <a:t>CLAUDE CODE FOR EVERYDAY WORK  ·  UCHICAGO × ANTHROPIC  ·  BATUHAN GUNDOGDU</a:t>
+            </a:r>
+            <a:endParaRPr lang="en-US" sz="1400" dirty="0"/>
+          </a:p>
+        </p:txBody>
+      </p:sp>
+      <p:sp>
+        <p:nvSpPr>
+          <p:cNvPr id="6" name="Text 4"/>
+          <p:cNvSpPr/>
+          <p:nvPr/>
+        </p:nvSpPr>
+        <p:spPr>
+          <a:xfrm>
+            <a:off x="822960" y="5029200"/>
+            <a:ext cx="10543032" cy="457200"/>
           </a:xfrm>
           <a:prstGeom prst="rect">
             <a:avLst/>
@@ -2481,17 +2490,17 @@
               <a:buNone/>
             </a:pPr>
             <a:r>
-              <a:rPr lang="en-US" sz="4000" b="1" dirty="0">
-                <a:solidFill>
-                  <a:srgbClr val="800000"/>
-                </a:solidFill>
-                <a:latin typeface="Calibri" pitchFamily="34" charset="0"/>
-                <a:ea typeface="Calibri" pitchFamily="34" charset="-122"/>
-                <a:cs typeface="Calibri" pitchFamily="34" charset="-120"/>
-              </a:rPr>
-              <a:t>Intro Session</a:t>
-            </a:r>
-            <a:endParaRPr lang="en-US" sz="4000" dirty="0"/>
+              <a:rPr lang="en-US" sz="1400" b="1" spc="200" kern="0" dirty="0">
+                <a:solidFill>
+                  <a:srgbClr val="2E7A72"/>
+                </a:solidFill>
+                <a:latin typeface="Avenir Next" pitchFamily="34" charset="0"/>
+                <a:ea typeface="Avenir Next" pitchFamily="34" charset="-122"/>
+                <a:cs typeface="Avenir Next" pitchFamily="34" charset="-120"/>
+              </a:rPr>
+              <a:t>INTRO SESSION</a:t>
+            </a:r>
+            <a:endParaRPr lang="en-US" sz="1400" dirty="0"/>
           </a:p>
         </p:txBody>
       </p:sp>
@@ -2520,40 +2529,16 @@
           <a:chExt cx="0" cy="0"/>
         </a:xfrm>
       </p:grpSpPr>
-      <p:pic>
-        <p:nvPicPr>
-          <p:cNvPr id="2" name="Image 0" descr="/Users/batuhangundogdu/Claude Code Workshop/deck/assets/uchicago-footer.png">    </p:cNvPr>
-          <p:cNvPicPr>
-            <a:picLocks noChangeAspect="1"/>
-          </p:cNvPicPr>
-          <p:nvPr/>
-        </p:nvPicPr>
-        <p:blipFill>
-          <a:blip r:embed="rId1"/>
-          <a:stretch>
-            <a:fillRect/>
-          </a:stretch>
-        </p:blipFill>
-        <p:spPr>
-          <a:xfrm>
-            <a:off x="539496" y="6382512"/>
-            <a:ext cx="2843784" cy="475488"/>
-          </a:xfrm>
-          <a:prstGeom prst="rect">
-            <a:avLst/>
-          </a:prstGeom>
-        </p:spPr>
-      </p:pic>
-      <p:sp>
-        <p:nvSpPr>
-          <p:cNvPr id="3" name="Text 0"/>
-          <p:cNvSpPr/>
-          <p:nvPr/>
-        </p:nvSpPr>
-        <p:spPr>
-          <a:xfrm>
-            <a:off x="548640" y="2468880"/>
-            <a:ext cx="11091672" cy="457200"/>
+      <p:sp>
+        <p:nvSpPr>
+          <p:cNvPr id="2" name="Text 0"/>
+          <p:cNvSpPr/>
+          <p:nvPr/>
+        </p:nvSpPr>
+        <p:spPr>
+          <a:xfrm>
+            <a:off x="822960" y="2514600"/>
+            <a:ext cx="10543032" cy="365760"/>
           </a:xfrm>
           <a:prstGeom prst="rect">
             <a:avLst/>
@@ -2569,30 +2554,50 @@
               <a:buNone/>
             </a:pPr>
             <a:r>
-              <a:rPr lang="en-US" sz="2400" spc="200" kern="0" dirty="0">
-                <a:solidFill>
-                  <a:srgbClr val="800000"/>
-                </a:solidFill>
-                <a:latin typeface="Calibri" pitchFamily="34" charset="0"/>
-                <a:ea typeface="Calibri" pitchFamily="34" charset="-122"/>
-                <a:cs typeface="Calibri" pitchFamily="34" charset="-120"/>
+              <a:rPr lang="en-US" sz="1500" b="1" spc="300" kern="0" dirty="0">
+                <a:solidFill>
+                  <a:srgbClr val="2E7A72"/>
+                </a:solidFill>
+                <a:latin typeface="Avenir Next" pitchFamily="34" charset="0"/>
+                <a:ea typeface="Avenir Next" pitchFamily="34" charset="-122"/>
+                <a:cs typeface="Avenir Next" pitchFamily="34" charset="-120"/>
               </a:rPr>
               <a:t>DEMO 2</a:t>
             </a:r>
-            <a:endParaRPr lang="en-US" sz="2400" dirty="0"/>
-          </a:p>
-        </p:txBody>
-      </p:sp>
-      <p:sp>
-        <p:nvSpPr>
-          <p:cNvPr id="4" name="Text 1"/>
-          <p:cNvSpPr/>
-          <p:nvPr/>
-        </p:nvSpPr>
-        <p:spPr>
-          <a:xfrm>
-            <a:off x="548640" y="2926080"/>
-            <a:ext cx="11091672" cy="1463040"/>
+            <a:endParaRPr lang="en-US" sz="1500" dirty="0"/>
+          </a:p>
+        </p:txBody>
+      </p:sp>
+      <p:sp>
+        <p:nvSpPr>
+          <p:cNvPr id="3" name="Shape 1"/>
+          <p:cNvSpPr/>
+          <p:nvPr/>
+        </p:nvSpPr>
+        <p:spPr>
+          <a:xfrm>
+            <a:off x="822960" y="2926080"/>
+            <a:ext cx="566928" cy="41148"/>
+          </a:xfrm>
+          <a:prstGeom prst="rect">
+            <a:avLst/>
+          </a:prstGeom>
+          <a:solidFill>
+            <a:srgbClr val="2E7A72"/>
+          </a:solidFill>
+          <a:ln/>
+        </p:spPr>
+      </p:sp>
+      <p:sp>
+        <p:nvSpPr>
+          <p:cNvPr id="4" name="Text 2"/>
+          <p:cNvSpPr/>
+          <p:nvPr/>
+        </p:nvSpPr>
+        <p:spPr>
+          <a:xfrm>
+            <a:off x="822960" y="3108960"/>
+            <a:ext cx="10543032" cy="1463040"/>
           </a:xfrm>
           <a:prstGeom prst="rect">
             <a:avLst/>
@@ -2605,20 +2610,23 @@
           <a:lstStyle/>
           <a:p>
             <a:pPr algn="l" indent="0" marL="0">
-              <a:buNone/>
-            </a:pPr>
-            <a:r>
-              <a:rPr lang="en-US" sz="5000" b="1" dirty="0">
-                <a:solidFill>
-                  <a:srgbClr val="000000"/>
-                </a:solidFill>
-                <a:latin typeface="Calibri" pitchFamily="34" charset="0"/>
-                <a:ea typeface="Calibri" pitchFamily="34" charset="-122"/>
-                <a:cs typeface="Calibri" pitchFamily="34" charset="-120"/>
+              <a:lnSpc>
+                <a:spcPct val="98000"/>
+              </a:lnSpc>
+              <a:buNone/>
+            </a:pPr>
+            <a:r>
+              <a:rPr lang="en-US" sz="4400" b="1" dirty="0">
+                <a:solidFill>
+                  <a:srgbClr val="111111"/>
+                </a:solidFill>
+                <a:latin typeface="Avenir Next" pitchFamily="34" charset="0"/>
+                <a:ea typeface="Avenir Next" pitchFamily="34" charset="-122"/>
+                <a:cs typeface="Avenir Next" pitchFamily="34" charset="-120"/>
               </a:rPr>
               <a:t>Research Paper Tracker</a:t>
             </a:r>
-            <a:endParaRPr lang="en-US" sz="5000" dirty="0"/>
+            <a:endParaRPr lang="en-US" sz="4400" dirty="0"/>
           </a:p>
         </p:txBody>
       </p:sp>
@@ -2647,40 +2655,16 @@
           <a:chExt cx="0" cy="0"/>
         </a:xfrm>
       </p:grpSpPr>
-      <p:pic>
-        <p:nvPicPr>
-          <p:cNvPr id="2" name="Image 0" descr="/Users/batuhangundogdu/Claude Code Workshop/deck/assets/uchicago-footer.png">    </p:cNvPr>
-          <p:cNvPicPr>
-            <a:picLocks noChangeAspect="1"/>
-          </p:cNvPicPr>
-          <p:nvPr/>
-        </p:nvPicPr>
-        <p:blipFill>
-          <a:blip r:embed="rId1"/>
-          <a:stretch>
-            <a:fillRect/>
-          </a:stretch>
-        </p:blipFill>
-        <p:spPr>
-          <a:xfrm>
-            <a:off x="539496" y="6382512"/>
-            <a:ext cx="2843784" cy="475488"/>
-          </a:xfrm>
-          <a:prstGeom prst="rect">
-            <a:avLst/>
-          </a:prstGeom>
-        </p:spPr>
-      </p:pic>
-      <p:sp>
-        <p:nvSpPr>
-          <p:cNvPr id="3" name="Text 0"/>
-          <p:cNvSpPr/>
-          <p:nvPr/>
-        </p:nvSpPr>
-        <p:spPr>
-          <a:xfrm>
-            <a:off x="548640" y="2468880"/>
-            <a:ext cx="11091672" cy="457200"/>
+      <p:sp>
+        <p:nvSpPr>
+          <p:cNvPr id="2" name="Text 0"/>
+          <p:cNvSpPr/>
+          <p:nvPr/>
+        </p:nvSpPr>
+        <p:spPr>
+          <a:xfrm>
+            <a:off x="822960" y="2514600"/>
+            <a:ext cx="10543032" cy="365760"/>
           </a:xfrm>
           <a:prstGeom prst="rect">
             <a:avLst/>
@@ -2696,30 +2680,50 @@
               <a:buNone/>
             </a:pPr>
             <a:r>
-              <a:rPr lang="en-US" sz="2400" spc="200" kern="0" dirty="0">
-                <a:solidFill>
-                  <a:srgbClr val="800000"/>
-                </a:solidFill>
-                <a:latin typeface="Calibri" pitchFamily="34" charset="0"/>
-                <a:ea typeface="Calibri" pitchFamily="34" charset="-122"/>
-                <a:cs typeface="Calibri" pitchFamily="34" charset="-120"/>
+              <a:rPr lang="en-US" sz="1500" b="1" spc="300" kern="0" dirty="0">
+                <a:solidFill>
+                  <a:srgbClr val="2E7A72"/>
+                </a:solidFill>
+                <a:latin typeface="Avenir Next" pitchFamily="34" charset="0"/>
+                <a:ea typeface="Avenir Next" pitchFamily="34" charset="-122"/>
+                <a:cs typeface="Avenir Next" pitchFamily="34" charset="-120"/>
               </a:rPr>
               <a:t>DEMO 3</a:t>
             </a:r>
-            <a:endParaRPr lang="en-US" sz="2400" dirty="0"/>
-          </a:p>
-        </p:txBody>
-      </p:sp>
-      <p:sp>
-        <p:nvSpPr>
-          <p:cNvPr id="4" name="Text 1"/>
-          <p:cNvSpPr/>
-          <p:nvPr/>
-        </p:nvSpPr>
-        <p:spPr>
-          <a:xfrm>
-            <a:off x="548640" y="2926080"/>
-            <a:ext cx="11091672" cy="1463040"/>
+            <a:endParaRPr lang="en-US" sz="1500" dirty="0"/>
+          </a:p>
+        </p:txBody>
+      </p:sp>
+      <p:sp>
+        <p:nvSpPr>
+          <p:cNvPr id="3" name="Shape 1"/>
+          <p:cNvSpPr/>
+          <p:nvPr/>
+        </p:nvSpPr>
+        <p:spPr>
+          <a:xfrm>
+            <a:off x="822960" y="2926080"/>
+            <a:ext cx="566928" cy="41148"/>
+          </a:xfrm>
+          <a:prstGeom prst="rect">
+            <a:avLst/>
+          </a:prstGeom>
+          <a:solidFill>
+            <a:srgbClr val="2E7A72"/>
+          </a:solidFill>
+          <a:ln/>
+        </p:spPr>
+      </p:sp>
+      <p:sp>
+        <p:nvSpPr>
+          <p:cNvPr id="4" name="Text 2"/>
+          <p:cNvSpPr/>
+          <p:nvPr/>
+        </p:nvSpPr>
+        <p:spPr>
+          <a:xfrm>
+            <a:off x="822960" y="3108960"/>
+            <a:ext cx="10543032" cy="1463040"/>
           </a:xfrm>
           <a:prstGeom prst="rect">
             <a:avLst/>
@@ -2732,20 +2736,23 @@
           <a:lstStyle/>
           <a:p>
             <a:pPr algn="l" indent="0" marL="0">
-              <a:buNone/>
-            </a:pPr>
-            <a:r>
-              <a:rPr lang="en-US" sz="5000" b="1" dirty="0">
-                <a:solidFill>
-                  <a:srgbClr val="000000"/>
-                </a:solidFill>
-                <a:latin typeface="Calibri" pitchFamily="34" charset="0"/>
-                <a:ea typeface="Calibri" pitchFamily="34" charset="-122"/>
-                <a:cs typeface="Calibri" pitchFamily="34" charset="-120"/>
+              <a:lnSpc>
+                <a:spcPct val="98000"/>
+              </a:lnSpc>
+              <a:buNone/>
+            </a:pPr>
+            <a:r>
+              <a:rPr lang="en-US" sz="4400" b="1" dirty="0">
+                <a:solidFill>
+                  <a:srgbClr val="111111"/>
+                </a:solidFill>
+                <a:latin typeface="Avenir Next" pitchFamily="34" charset="0"/>
+                <a:ea typeface="Avenir Next" pitchFamily="34" charset="-122"/>
+                <a:cs typeface="Avenir Next" pitchFamily="34" charset="-120"/>
               </a:rPr>
               <a:t>Daily Dashboard</a:t>
             </a:r>
-            <a:endParaRPr lang="en-US" sz="5000" dirty="0"/>
+            <a:endParaRPr lang="en-US" sz="4400" dirty="0"/>
           </a:p>
         </p:txBody>
       </p:sp>
@@ -2774,40 +2781,16 @@
           <a:chExt cx="0" cy="0"/>
         </a:xfrm>
       </p:grpSpPr>
-      <p:pic>
-        <p:nvPicPr>
-          <p:cNvPr id="2" name="Image 0" descr="/Users/batuhangundogdu/Claude Code Workshop/deck/assets/uchicago-footer.png">    </p:cNvPr>
-          <p:cNvPicPr>
-            <a:picLocks noChangeAspect="1"/>
-          </p:cNvPicPr>
-          <p:nvPr/>
-        </p:nvPicPr>
-        <p:blipFill>
-          <a:blip r:embed="rId1"/>
-          <a:stretch>
-            <a:fillRect/>
-          </a:stretch>
-        </p:blipFill>
-        <p:spPr>
-          <a:xfrm>
-            <a:off x="539496" y="6382512"/>
-            <a:ext cx="2843784" cy="475488"/>
-          </a:xfrm>
-          <a:prstGeom prst="rect">
-            <a:avLst/>
-          </a:prstGeom>
-        </p:spPr>
-      </p:pic>
-      <p:sp>
-        <p:nvSpPr>
-          <p:cNvPr id="3" name="Text 0"/>
-          <p:cNvSpPr/>
-          <p:nvPr/>
-        </p:nvSpPr>
-        <p:spPr>
-          <a:xfrm>
-            <a:off x="548640" y="2468880"/>
-            <a:ext cx="11091672" cy="457200"/>
+      <p:sp>
+        <p:nvSpPr>
+          <p:cNvPr id="2" name="Text 0"/>
+          <p:cNvSpPr/>
+          <p:nvPr/>
+        </p:nvSpPr>
+        <p:spPr>
+          <a:xfrm>
+            <a:off x="822960" y="2514600"/>
+            <a:ext cx="10543032" cy="365760"/>
           </a:xfrm>
           <a:prstGeom prst="rect">
             <a:avLst/>
@@ -2823,30 +2806,50 @@
               <a:buNone/>
             </a:pPr>
             <a:r>
-              <a:rPr lang="en-US" sz="2400" spc="200" kern="0" dirty="0">
-                <a:solidFill>
-                  <a:srgbClr val="800000"/>
-                </a:solidFill>
-                <a:latin typeface="Calibri" pitchFamily="34" charset="0"/>
-                <a:ea typeface="Calibri" pitchFamily="34" charset="-122"/>
-                <a:cs typeface="Calibri" pitchFamily="34" charset="-120"/>
+              <a:rPr lang="en-US" sz="1500" b="1" spc="300" kern="0" dirty="0">
+                <a:solidFill>
+                  <a:srgbClr val="2E7A72"/>
+                </a:solidFill>
+                <a:latin typeface="Avenir Next" pitchFamily="34" charset="0"/>
+                <a:ea typeface="Avenir Next" pitchFamily="34" charset="-122"/>
+                <a:cs typeface="Avenir Next" pitchFamily="34" charset="-120"/>
               </a:rPr>
               <a:t>DEMO 4</a:t>
             </a:r>
-            <a:endParaRPr lang="en-US" sz="2400" dirty="0"/>
-          </a:p>
-        </p:txBody>
-      </p:sp>
-      <p:sp>
-        <p:nvSpPr>
-          <p:cNvPr id="4" name="Text 1"/>
-          <p:cNvSpPr/>
-          <p:nvPr/>
-        </p:nvSpPr>
-        <p:spPr>
-          <a:xfrm>
-            <a:off x="548640" y="2926080"/>
-            <a:ext cx="11091672" cy="1463040"/>
+            <a:endParaRPr lang="en-US" sz="1500" dirty="0"/>
+          </a:p>
+        </p:txBody>
+      </p:sp>
+      <p:sp>
+        <p:nvSpPr>
+          <p:cNvPr id="3" name="Shape 1"/>
+          <p:cNvSpPr/>
+          <p:nvPr/>
+        </p:nvSpPr>
+        <p:spPr>
+          <a:xfrm>
+            <a:off x="822960" y="2926080"/>
+            <a:ext cx="566928" cy="41148"/>
+          </a:xfrm>
+          <a:prstGeom prst="rect">
+            <a:avLst/>
+          </a:prstGeom>
+          <a:solidFill>
+            <a:srgbClr val="2E7A72"/>
+          </a:solidFill>
+          <a:ln/>
+        </p:spPr>
+      </p:sp>
+      <p:sp>
+        <p:nvSpPr>
+          <p:cNvPr id="4" name="Text 2"/>
+          <p:cNvSpPr/>
+          <p:nvPr/>
+        </p:nvSpPr>
+        <p:spPr>
+          <a:xfrm>
+            <a:off x="822960" y="3108960"/>
+            <a:ext cx="10543032" cy="1463040"/>
           </a:xfrm>
           <a:prstGeom prst="rect">
             <a:avLst/>
@@ -2859,20 +2862,23 @@
           <a:lstStyle/>
           <a:p>
             <a:pPr algn="l" indent="0" marL="0">
-              <a:buNone/>
-            </a:pPr>
-            <a:r>
-              <a:rPr lang="en-US" sz="5000" b="1" dirty="0">
-                <a:solidFill>
-                  <a:srgbClr val="000000"/>
-                </a:solidFill>
-                <a:latin typeface="Calibri" pitchFamily="34" charset="0"/>
-                <a:ea typeface="Calibri" pitchFamily="34" charset="-122"/>
-                <a:cs typeface="Calibri" pitchFamily="34" charset="-120"/>
+              <a:lnSpc>
+                <a:spcPct val="98000"/>
+              </a:lnSpc>
+              <a:buNone/>
+            </a:pPr>
+            <a:r>
+              <a:rPr lang="en-US" sz="4400" b="1" dirty="0">
+                <a:solidFill>
+                  <a:srgbClr val="111111"/>
+                </a:solidFill>
+                <a:latin typeface="Avenir Next" pitchFamily="34" charset="0"/>
+                <a:ea typeface="Avenir Next" pitchFamily="34" charset="-122"/>
+                <a:cs typeface="Avenir Next" pitchFamily="34" charset="-120"/>
               </a:rPr>
               <a:t>Teaching Assistant</a:t>
             </a:r>
-            <a:endParaRPr lang="en-US" sz="5000" dirty="0"/>
+            <a:endParaRPr lang="en-US" sz="4400" dirty="0"/>
           </a:p>
         </p:txBody>
       </p:sp>
@@ -2901,40 +2907,16 @@
           <a:chExt cx="0" cy="0"/>
         </a:xfrm>
       </p:grpSpPr>
-      <p:pic>
-        <p:nvPicPr>
-          <p:cNvPr id="2" name="Image 0" descr="/Users/batuhangundogdu/Claude Code Workshop/deck/assets/uchicago-footer.png">    </p:cNvPr>
-          <p:cNvPicPr>
-            <a:picLocks noChangeAspect="1"/>
-          </p:cNvPicPr>
-          <p:nvPr/>
-        </p:nvPicPr>
-        <p:blipFill>
-          <a:blip r:embed="rId1"/>
-          <a:stretch>
-            <a:fillRect/>
-          </a:stretch>
-        </p:blipFill>
-        <p:spPr>
-          <a:xfrm>
-            <a:off x="539496" y="6382512"/>
-            <a:ext cx="2843784" cy="475488"/>
-          </a:xfrm>
-          <a:prstGeom prst="rect">
-            <a:avLst/>
-          </a:prstGeom>
-        </p:spPr>
-      </p:pic>
-      <p:sp>
-        <p:nvSpPr>
-          <p:cNvPr id="3" name="Text 0"/>
-          <p:cNvSpPr/>
-          <p:nvPr/>
-        </p:nvSpPr>
-        <p:spPr>
-          <a:xfrm>
-            <a:off x="548640" y="365760"/>
-            <a:ext cx="11091672" cy="1188720"/>
+      <p:sp>
+        <p:nvSpPr>
+          <p:cNvPr id="2" name="Text 0"/>
+          <p:cNvSpPr/>
+          <p:nvPr/>
+        </p:nvSpPr>
+        <p:spPr>
+          <a:xfrm>
+            <a:off x="822960" y="658368"/>
+            <a:ext cx="10543032" cy="274320"/>
           </a:xfrm>
           <a:prstGeom prst="rect">
             <a:avLst/>
@@ -2950,30 +2932,92 @@
               <a:buNone/>
             </a:pPr>
             <a:r>
-              <a:rPr lang="en-US" sz="5000" b="1" dirty="0">
-                <a:solidFill>
-                  <a:srgbClr val="000000"/>
-                </a:solidFill>
-                <a:latin typeface="Calibri" pitchFamily="34" charset="0"/>
-                <a:ea typeface="Calibri" pitchFamily="34" charset="-122"/>
-                <a:cs typeface="Calibri" pitchFamily="34" charset="-120"/>
+              <a:rPr lang="en-US" sz="1200" b="1" spc="250" kern="0" dirty="0">
+                <a:solidFill>
+                  <a:srgbClr val="9A9A9A"/>
+                </a:solidFill>
+                <a:latin typeface="Avenir Next" pitchFamily="34" charset="0"/>
+                <a:ea typeface="Avenir Next" pitchFamily="34" charset="-122"/>
+                <a:cs typeface="Avenir Next" pitchFamily="34" charset="-120"/>
+              </a:rPr>
+              <a:t>THE RECURRING BEAT</a:t>
+            </a:r>
+            <a:endParaRPr lang="en-US" sz="1200" dirty="0"/>
+          </a:p>
+        </p:txBody>
+      </p:sp>
+      <p:sp>
+        <p:nvSpPr>
+          <p:cNvPr id="3" name="Shape 1"/>
+          <p:cNvSpPr/>
+          <p:nvPr/>
+        </p:nvSpPr>
+        <p:spPr>
+          <a:xfrm>
+            <a:off x="822960" y="969264"/>
+            <a:ext cx="566928" cy="41148"/>
+          </a:xfrm>
+          <a:prstGeom prst="rect">
+            <a:avLst/>
+          </a:prstGeom>
+          <a:solidFill>
+            <a:srgbClr val="2E7A72"/>
+          </a:solidFill>
+          <a:ln/>
+        </p:spPr>
+      </p:sp>
+      <p:sp>
+        <p:nvSpPr>
+          <p:cNvPr id="4" name="Text 2"/>
+          <p:cNvSpPr/>
+          <p:nvPr/>
+        </p:nvSpPr>
+        <p:spPr>
+          <a:xfrm>
+            <a:off x="822960" y="1161288"/>
+            <a:ext cx="10543032" cy="1188720"/>
+          </a:xfrm>
+          <a:prstGeom prst="rect">
+            <a:avLst/>
+          </a:prstGeom>
+          <a:noFill/>
+          <a:ln/>
+        </p:spPr>
+        <p:txBody>
+          <a:bodyPr wrap="square" lIns="0" tIns="0" rIns="0" bIns="0" rtlCol="0" anchor="t"/>
+          <a:lstStyle/>
+          <a:p>
+            <a:pPr algn="l" indent="0" marL="0">
+              <a:lnSpc>
+                <a:spcPct val="98000"/>
+              </a:lnSpc>
+              <a:buNone/>
+            </a:pPr>
+            <a:r>
+              <a:rPr lang="en-US" sz="4000" b="1" dirty="0">
+                <a:solidFill>
+                  <a:srgbClr val="111111"/>
+                </a:solidFill>
+                <a:latin typeface="Avenir Next" pitchFamily="34" charset="0"/>
+                <a:ea typeface="Avenir Next" pitchFamily="34" charset="-122"/>
+                <a:cs typeface="Avenir Next" pitchFamily="34" charset="-120"/>
               </a:rPr>
               <a:t>Don't like it? Just say so.</a:t>
             </a:r>
-            <a:endParaRPr lang="en-US" sz="5000" dirty="0"/>
-          </a:p>
-        </p:txBody>
-      </p:sp>
-      <p:sp>
-        <p:nvSpPr>
-          <p:cNvPr id="4" name="Text 1"/>
-          <p:cNvSpPr/>
-          <p:nvPr/>
-        </p:nvSpPr>
-        <p:spPr>
-          <a:xfrm>
-            <a:off x="548640" y="1920240"/>
-            <a:ext cx="11091672" cy="4297680"/>
+            <a:endParaRPr lang="en-US" sz="4000" dirty="0"/>
+          </a:p>
+        </p:txBody>
+      </p:sp>
+      <p:sp>
+        <p:nvSpPr>
+          <p:cNvPr id="5" name="Text 3"/>
+          <p:cNvSpPr/>
+          <p:nvPr/>
+        </p:nvSpPr>
+        <p:spPr>
+          <a:xfrm>
+            <a:off x="822960" y="2441448"/>
+            <a:ext cx="10543032" cy="3959352"/>
           </a:xfrm>
           <a:prstGeom prst="rect">
             <a:avLst/>
@@ -2987,106 +3031,106 @@
           <a:p>
             <a:pPr algn="l" indent="0" marL="0">
               <a:lnSpc>
-                <a:spcPct val="110000"/>
+                <a:spcPct val="115000"/>
               </a:lnSpc>
               <a:spcAft>
-                <a:spcPts val="1800"/>
+                <a:spcPts val="1600"/>
               </a:spcAft>
               <a:buNone/>
             </a:pPr>
             <a:r>
-              <a:rPr lang="en-US" sz="2800" dirty="0">
-                <a:solidFill>
-                  <a:srgbClr val="0070C0"/>
-                </a:solidFill>
-                <a:latin typeface="Calibri" pitchFamily="34" charset="0"/>
-                <a:ea typeface="Calibri" pitchFamily="34" charset="-122"/>
-                <a:cs typeface="Calibri" pitchFamily="34" charset="-120"/>
+              <a:rPr lang="en-US" sz="2000" dirty="0">
+                <a:solidFill>
+                  <a:srgbClr val="2E7A72"/>
+                </a:solidFill>
+                <a:latin typeface="Avenir Next" pitchFamily="34" charset="0"/>
+                <a:ea typeface="Avenir Next" pitchFamily="34" charset="-122"/>
+                <a:cs typeface="Avenir Next" pitchFamily="34" charset="-120"/>
               </a:rPr>
               <a:t>“Make it dark.”</a:t>
             </a:r>
-            <a:endParaRPr lang="en-US" sz="2800" dirty="0"/>
+            <a:endParaRPr lang="en-US" sz="2000" dirty="0"/>
           </a:p>
           <a:p>
             <a:pPr algn="l" indent="0" marL="0">
               <a:lnSpc>
-                <a:spcPct val="110000"/>
+                <a:spcPct val="115000"/>
               </a:lnSpc>
               <a:spcAft>
-                <a:spcPts val="1800"/>
+                <a:spcPts val="1600"/>
               </a:spcAft>
               <a:buNone/>
             </a:pPr>
             <a:r>
-              <a:rPr lang="en-US" sz="2800" dirty="0">
-                <a:solidFill>
-                  <a:srgbClr val="0070C0"/>
-                </a:solidFill>
-                <a:latin typeface="Calibri" pitchFamily="34" charset="0"/>
-                <a:ea typeface="Calibri" pitchFamily="34" charset="-122"/>
-                <a:cs typeface="Calibri" pitchFamily="34" charset="-120"/>
+              <a:rPr lang="en-US" sz="2000" dirty="0">
+                <a:solidFill>
+                  <a:srgbClr val="2E7A72"/>
+                </a:solidFill>
+                <a:latin typeface="Avenir Next" pitchFamily="34" charset="0"/>
+                <a:ea typeface="Avenir Next" pitchFamily="34" charset="-122"/>
+                <a:cs typeface="Avenir Next" pitchFamily="34" charset="-120"/>
               </a:rPr>
               <a:t>“Move the total to the top.”</a:t>
             </a:r>
-            <a:endParaRPr lang="en-US" sz="2800" dirty="0"/>
+            <a:endParaRPr lang="en-US" sz="2000" dirty="0"/>
           </a:p>
           <a:p>
             <a:pPr algn="l" indent="0" marL="0">
               <a:lnSpc>
-                <a:spcPct val="110000"/>
+                <a:spcPct val="115000"/>
               </a:lnSpc>
               <a:spcAft>
-                <a:spcPts val="1800"/>
+                <a:spcPts val="1600"/>
               </a:spcAft>
               <a:buNone/>
             </a:pPr>
             <a:r>
-              <a:rPr lang="en-US" sz="2800" dirty="0">
-                <a:solidFill>
-                  <a:srgbClr val="0070C0"/>
-                </a:solidFill>
-                <a:latin typeface="Calibri" pitchFamily="34" charset="0"/>
-                <a:ea typeface="Calibri" pitchFamily="34" charset="-122"/>
-                <a:cs typeface="Calibri" pitchFamily="34" charset="-120"/>
+              <a:rPr lang="en-US" sz="2000" dirty="0">
+                <a:solidFill>
+                  <a:srgbClr val="2E7A72"/>
+                </a:solidFill>
+                <a:latin typeface="Avenir Next" pitchFamily="34" charset="0"/>
+                <a:ea typeface="Avenir Next" pitchFamily="34" charset="-122"/>
+                <a:cs typeface="Avenir Next" pitchFamily="34" charset="-120"/>
               </a:rPr>
               <a:t>“Add a pie chart.”</a:t>
             </a:r>
-            <a:endParaRPr lang="en-US" sz="2800" dirty="0"/>
+            <a:endParaRPr lang="en-US" sz="2000" dirty="0"/>
           </a:p>
           <a:p>
             <a:pPr algn="l" indent="0" marL="0">
               <a:lnSpc>
-                <a:spcPct val="110000"/>
+                <a:spcPct val="115000"/>
               </a:lnSpc>
               <a:spcAft>
-                <a:spcPts val="1800"/>
+                <a:spcPts val="1600"/>
               </a:spcAft>
               <a:buNone/>
             </a:pPr>
-            <a:endParaRPr lang="en-US" sz="2800" dirty="0"/>
+            <a:endParaRPr lang="en-US" sz="2000" dirty="0"/>
           </a:p>
           <a:p>
             <a:pPr algn="l" indent="0" marL="0">
               <a:lnSpc>
-                <a:spcPct val="110000"/>
+                <a:spcPct val="115000"/>
               </a:lnSpc>
               <a:spcAft>
-                <a:spcPts val="1800"/>
+                <a:spcPts val="1600"/>
               </a:spcAft>
               <a:buNone/>
             </a:pPr>
             <a:r>
-              <a:rPr lang="en-US" sz="2800" dirty="0">
-                <a:solidFill>
-                  <a:srgbClr val="00B050"/>
-                </a:solidFill>
-                <a:latin typeface="Calibri" pitchFamily="34" charset="0"/>
-                <a:ea typeface="Calibri" pitchFamily="34" charset="-122"/>
-                <a:cs typeface="Calibri" pitchFamily="34" charset="-120"/>
+              <a:rPr lang="en-US" sz="2000" dirty="0">
+                <a:solidFill>
+                  <a:srgbClr val="2E7A72"/>
+                </a:solidFill>
+                <a:latin typeface="Avenir Next" pitchFamily="34" charset="0"/>
+                <a:ea typeface="Avenir Next" pitchFamily="34" charset="-122"/>
+                <a:cs typeface="Avenir Next" pitchFamily="34" charset="-120"/>
               </a:rPr>
               <a:t>No menus. No settings. No code. Just words.</a:t>
             </a:r>
-            <a:endParaRPr lang="en-US" sz="2800" dirty="0"/>
+            <a:endParaRPr lang="en-US" sz="2000" dirty="0"/>
           </a:p>
         </p:txBody>
       </p:sp>
@@ -3115,40 +3159,16 @@
           <a:chExt cx="0" cy="0"/>
         </a:xfrm>
       </p:grpSpPr>
-      <p:pic>
-        <p:nvPicPr>
-          <p:cNvPr id="2" name="Image 0" descr="/Users/batuhangundogdu/Claude Code Workshop/deck/assets/uchicago-footer.png">    </p:cNvPr>
-          <p:cNvPicPr>
-            <a:picLocks noChangeAspect="1"/>
-          </p:cNvPicPr>
-          <p:nvPr/>
-        </p:nvPicPr>
-        <p:blipFill>
-          <a:blip r:embed="rId1"/>
-          <a:stretch>
-            <a:fillRect/>
-          </a:stretch>
-        </p:blipFill>
-        <p:spPr>
-          <a:xfrm>
-            <a:off x="539496" y="6382512"/>
-            <a:ext cx="2843784" cy="475488"/>
-          </a:xfrm>
-          <a:prstGeom prst="rect">
-            <a:avLst/>
-          </a:prstGeom>
-        </p:spPr>
-      </p:pic>
-      <p:sp>
-        <p:nvSpPr>
-          <p:cNvPr id="3" name="Text 0"/>
-          <p:cNvSpPr/>
-          <p:nvPr/>
-        </p:nvSpPr>
-        <p:spPr>
-          <a:xfrm>
-            <a:off x="548640" y="2468880"/>
-            <a:ext cx="11091672" cy="457200"/>
+      <p:sp>
+        <p:nvSpPr>
+          <p:cNvPr id="2" name="Text 0"/>
+          <p:cNvSpPr/>
+          <p:nvPr/>
+        </p:nvSpPr>
+        <p:spPr>
+          <a:xfrm>
+            <a:off x="822960" y="2514600"/>
+            <a:ext cx="10543032" cy="365760"/>
           </a:xfrm>
           <a:prstGeom prst="rect">
             <a:avLst/>
@@ -3164,30 +3184,50 @@
               <a:buNone/>
             </a:pPr>
             <a:r>
-              <a:rPr lang="en-US" sz="2400" spc="200" kern="0" dirty="0">
-                <a:solidFill>
-                  <a:srgbClr val="800000"/>
-                </a:solidFill>
-                <a:latin typeface="Calibri" pitchFamily="34" charset="0"/>
-                <a:ea typeface="Calibri" pitchFamily="34" charset="-122"/>
-                <a:cs typeface="Calibri" pitchFamily="34" charset="-120"/>
+              <a:rPr lang="en-US" sz="1500" b="1" spc="300" kern="0" dirty="0">
+                <a:solidFill>
+                  <a:srgbClr val="2E7A72"/>
+                </a:solidFill>
+                <a:latin typeface="Avenir Next" pitchFamily="34" charset="0"/>
+                <a:ea typeface="Avenir Next" pitchFamily="34" charset="-122"/>
+                <a:cs typeface="Avenir Next" pitchFamily="34" charset="-120"/>
               </a:rPr>
               <a:t>PART THREE</a:t>
             </a:r>
-            <a:endParaRPr lang="en-US" sz="2400" dirty="0"/>
-          </a:p>
-        </p:txBody>
-      </p:sp>
-      <p:sp>
-        <p:nvSpPr>
-          <p:cNvPr id="4" name="Text 1"/>
-          <p:cNvSpPr/>
-          <p:nvPr/>
-        </p:nvSpPr>
-        <p:spPr>
-          <a:xfrm>
-            <a:off x="548640" y="2926080"/>
-            <a:ext cx="11091672" cy="1463040"/>
+            <a:endParaRPr lang="en-US" sz="1500" dirty="0"/>
+          </a:p>
+        </p:txBody>
+      </p:sp>
+      <p:sp>
+        <p:nvSpPr>
+          <p:cNvPr id="3" name="Shape 1"/>
+          <p:cNvSpPr/>
+          <p:nvPr/>
+        </p:nvSpPr>
+        <p:spPr>
+          <a:xfrm>
+            <a:off x="822960" y="2926080"/>
+            <a:ext cx="566928" cy="41148"/>
+          </a:xfrm>
+          <a:prstGeom prst="rect">
+            <a:avLst/>
+          </a:prstGeom>
+          <a:solidFill>
+            <a:srgbClr val="2E7A72"/>
+          </a:solidFill>
+          <a:ln/>
+        </p:spPr>
+      </p:sp>
+      <p:sp>
+        <p:nvSpPr>
+          <p:cNvPr id="4" name="Text 2"/>
+          <p:cNvSpPr/>
+          <p:nvPr/>
+        </p:nvSpPr>
+        <p:spPr>
+          <a:xfrm>
+            <a:off x="822960" y="3108960"/>
+            <a:ext cx="10543032" cy="1463040"/>
           </a:xfrm>
           <a:prstGeom prst="rect">
             <a:avLst/>
@@ -3200,20 +3240,23 @@
           <a:lstStyle/>
           <a:p>
             <a:pPr algn="l" indent="0" marL="0">
-              <a:buNone/>
-            </a:pPr>
-            <a:r>
-              <a:rPr lang="en-US" sz="5000" b="1" dirty="0">
-                <a:solidFill>
-                  <a:srgbClr val="000000"/>
-                </a:solidFill>
-                <a:latin typeface="Calibri" pitchFamily="34" charset="0"/>
-                <a:ea typeface="Calibri" pitchFamily="34" charset="-122"/>
-                <a:cs typeface="Calibri" pitchFamily="34" charset="-120"/>
+              <a:lnSpc>
+                <a:spcPct val="98000"/>
+              </a:lnSpc>
+              <a:buNone/>
+            </a:pPr>
+            <a:r>
+              <a:rPr lang="en-US" sz="4400" b="1" dirty="0">
+                <a:solidFill>
+                  <a:srgbClr val="111111"/>
+                </a:solidFill>
+                <a:latin typeface="Avenir Next" pitchFamily="34" charset="0"/>
+                <a:ea typeface="Avenir Next" pitchFamily="34" charset="-122"/>
+                <a:cs typeface="Avenir Next" pitchFamily="34" charset="-120"/>
               </a:rPr>
               <a:t>The reveal</a:t>
             </a:r>
-            <a:endParaRPr lang="en-US" sz="5000" dirty="0"/>
+            <a:endParaRPr lang="en-US" sz="4400" dirty="0"/>
           </a:p>
         </p:txBody>
       </p:sp>
@@ -3242,40 +3285,16 @@
           <a:chExt cx="0" cy="0"/>
         </a:xfrm>
       </p:grpSpPr>
-      <p:pic>
-        <p:nvPicPr>
-          <p:cNvPr id="2" name="Image 0" descr="/Users/batuhangundogdu/Claude Code Workshop/deck/assets/uchicago-footer.png">    </p:cNvPr>
-          <p:cNvPicPr>
-            <a:picLocks noChangeAspect="1"/>
-          </p:cNvPicPr>
-          <p:nvPr/>
-        </p:nvPicPr>
-        <p:blipFill>
-          <a:blip r:embed="rId1"/>
-          <a:stretch>
-            <a:fillRect/>
-          </a:stretch>
-        </p:blipFill>
-        <p:spPr>
-          <a:xfrm>
-            <a:off x="539496" y="6382512"/>
-            <a:ext cx="2843784" cy="475488"/>
-          </a:xfrm>
-          <a:prstGeom prst="rect">
-            <a:avLst/>
-          </a:prstGeom>
-        </p:spPr>
-      </p:pic>
-      <p:sp>
-        <p:nvSpPr>
-          <p:cNvPr id="3" name="Text 0"/>
-          <p:cNvSpPr/>
-          <p:nvPr/>
-        </p:nvSpPr>
-        <p:spPr>
-          <a:xfrm>
-            <a:off x="548640" y="1554480"/>
-            <a:ext cx="11091672" cy="2743200"/>
+      <p:sp>
+        <p:nvSpPr>
+          <p:cNvPr id="2" name="Text 0"/>
+          <p:cNvSpPr/>
+          <p:nvPr/>
+        </p:nvSpPr>
+        <p:spPr>
+          <a:xfrm>
+            <a:off x="822960" y="658368"/>
+            <a:ext cx="10543032" cy="274320"/>
           </a:xfrm>
           <a:prstGeom prst="rect">
             <a:avLst/>
@@ -3284,6 +3303,65 @@
           <a:ln/>
         </p:spPr>
         <p:txBody>
+          <a:bodyPr wrap="square" lIns="0" tIns="0" rIns="0" bIns="0" rtlCol="0" anchor="t"/>
+          <a:lstStyle/>
+          <a:p>
+            <a:pPr algn="l" indent="0" marL="0">
+              <a:buNone/>
+            </a:pPr>
+            <a:r>
+              <a:rPr lang="en-US" sz="1200" b="1" spc="250" kern="0" dirty="0">
+                <a:solidFill>
+                  <a:srgbClr val="9A9A9A"/>
+                </a:solidFill>
+                <a:latin typeface="Avenir Next" pitchFamily="34" charset="0"/>
+                <a:ea typeface="Avenir Next" pitchFamily="34" charset="-122"/>
+                <a:cs typeface="Avenir Next" pitchFamily="34" charset="-120"/>
+              </a:rPr>
+              <a:t>THE WHOLE THING</a:t>
+            </a:r>
+            <a:endParaRPr lang="en-US" sz="1200" dirty="0"/>
+          </a:p>
+        </p:txBody>
+      </p:sp>
+      <p:sp>
+        <p:nvSpPr>
+          <p:cNvPr id="3" name="Shape 1"/>
+          <p:cNvSpPr/>
+          <p:nvPr/>
+        </p:nvSpPr>
+        <p:spPr>
+          <a:xfrm>
+            <a:off x="822960" y="969264"/>
+            <a:ext cx="566928" cy="41148"/>
+          </a:xfrm>
+          <a:prstGeom prst="rect">
+            <a:avLst/>
+          </a:prstGeom>
+          <a:solidFill>
+            <a:srgbClr val="2E7A72"/>
+          </a:solidFill>
+          <a:ln/>
+        </p:spPr>
+      </p:sp>
+      <p:sp>
+        <p:nvSpPr>
+          <p:cNvPr id="4" name="Text 2"/>
+          <p:cNvSpPr/>
+          <p:nvPr/>
+        </p:nvSpPr>
+        <p:spPr>
+          <a:xfrm>
+            <a:off x="777240" y="1371600"/>
+            <a:ext cx="10543032" cy="2926080"/>
+          </a:xfrm>
+          <a:prstGeom prst="rect">
+            <a:avLst/>
+          </a:prstGeom>
+          <a:noFill/>
+          <a:ln/>
+        </p:spPr>
+        <p:txBody>
           <a:bodyPr wrap="square" lIns="0" tIns="0" rIns="0" bIns="0" rtlCol="0" anchor="ctr"/>
           <a:lstStyle/>
           <a:p>
@@ -3291,30 +3369,30 @@
               <a:buNone/>
             </a:pPr>
             <a:r>
-              <a:rPr lang="en-US" sz="14000" b="1" dirty="0">
-                <a:solidFill>
-                  <a:srgbClr val="800000"/>
-                </a:solidFill>
-                <a:latin typeface="Calibri" pitchFamily="34" charset="0"/>
-                <a:ea typeface="Calibri" pitchFamily="34" charset="-122"/>
-                <a:cs typeface="Calibri" pitchFamily="34" charset="-120"/>
+              <a:rPr lang="en-US" sz="13000" b="1" dirty="0">
+                <a:solidFill>
+                  <a:srgbClr val="2E7A72"/>
+                </a:solidFill>
+                <a:latin typeface="Avenir Next" pitchFamily="34" charset="0"/>
+                <a:ea typeface="Avenir Next" pitchFamily="34" charset="-122"/>
+                <a:cs typeface="Avenir Next" pitchFamily="34" charset="-120"/>
               </a:rPr>
               <a:t>1</a:t>
             </a:r>
-            <a:endParaRPr lang="en-US" sz="14000" dirty="0"/>
-          </a:p>
-        </p:txBody>
-      </p:sp>
-      <p:sp>
-        <p:nvSpPr>
-          <p:cNvPr id="4" name="Text 1"/>
-          <p:cNvSpPr/>
-          <p:nvPr/>
-        </p:nvSpPr>
-        <p:spPr>
-          <a:xfrm>
-            <a:off x="548640" y="4389120"/>
-            <a:ext cx="11091672" cy="914400"/>
+            <a:endParaRPr lang="en-US" sz="13000" dirty="0"/>
+          </a:p>
+        </p:txBody>
+      </p:sp>
+      <p:sp>
+        <p:nvSpPr>
+          <p:cNvPr id="5" name="Text 3"/>
+          <p:cNvSpPr/>
+          <p:nvPr/>
+        </p:nvSpPr>
+        <p:spPr>
+          <a:xfrm>
+            <a:off x="822960" y="4480560"/>
+            <a:ext cx="8714232" cy="1280160"/>
           </a:xfrm>
           <a:prstGeom prst="rect">
             <a:avLst/>
@@ -3327,20 +3405,23 @@
           <a:lstStyle/>
           <a:p>
             <a:pPr algn="l" indent="0" marL="0">
-              <a:buNone/>
-            </a:pPr>
-            <a:r>
-              <a:rPr lang="en-US" sz="2400" dirty="0">
-                <a:solidFill>
-                  <a:srgbClr val="000000"/>
-                </a:solidFill>
-                <a:latin typeface="Calibri" pitchFamily="34" charset="0"/>
-                <a:ea typeface="Calibri" pitchFamily="34" charset="-122"/>
-                <a:cs typeface="Calibri" pitchFamily="34" charset="-120"/>
+              <a:lnSpc>
+                <a:spcPct val="120000"/>
+              </a:lnSpc>
+              <a:buNone/>
+            </a:pPr>
+            <a:r>
+              <a:rPr lang="en-US" sz="1500" dirty="0">
+                <a:solidFill>
+                  <a:srgbClr val="111111"/>
+                </a:solidFill>
+                <a:latin typeface="Avenir Next" pitchFamily="34" charset="0"/>
+                <a:ea typeface="Avenir Next" pitchFamily="34" charset="-122"/>
+                <a:cs typeface="Avenir Next" pitchFamily="34" charset="-120"/>
               </a:rPr>
               <a:t>Claude Code session built this whole workshop - these slides and all four apps. No template. No help. Just conversation.</a:t>
             </a:r>
-            <a:endParaRPr lang="en-US" sz="2400" dirty="0"/>
+            <a:endParaRPr lang="en-US" sz="1500" dirty="0"/>
           </a:p>
         </p:txBody>
       </p:sp>
@@ -3369,40 +3450,16 @@
           <a:chExt cx="0" cy="0"/>
         </a:xfrm>
       </p:grpSpPr>
-      <p:pic>
-        <p:nvPicPr>
-          <p:cNvPr id="2" name="Image 0" descr="/Users/batuhangundogdu/Claude Code Workshop/deck/assets/uchicago-footer.png">    </p:cNvPr>
-          <p:cNvPicPr>
-            <a:picLocks noChangeAspect="1"/>
-          </p:cNvPicPr>
-          <p:nvPr/>
-        </p:nvPicPr>
-        <p:blipFill>
-          <a:blip r:embed="rId1"/>
-          <a:stretch>
-            <a:fillRect/>
-          </a:stretch>
-        </p:blipFill>
-        <p:spPr>
-          <a:xfrm>
-            <a:off x="539496" y="6382512"/>
-            <a:ext cx="2843784" cy="475488"/>
-          </a:xfrm>
-          <a:prstGeom prst="rect">
-            <a:avLst/>
-          </a:prstGeom>
-        </p:spPr>
-      </p:pic>
-      <p:sp>
-        <p:nvSpPr>
-          <p:cNvPr id="3" name="Text 0"/>
-          <p:cNvSpPr/>
-          <p:nvPr/>
-        </p:nvSpPr>
-        <p:spPr>
-          <a:xfrm>
-            <a:off x="548640" y="365760"/>
-            <a:ext cx="11091672" cy="1188720"/>
+      <p:sp>
+        <p:nvSpPr>
+          <p:cNvPr id="2" name="Text 0"/>
+          <p:cNvSpPr/>
+          <p:nvPr/>
+        </p:nvSpPr>
+        <p:spPr>
+          <a:xfrm>
+            <a:off x="822960" y="658368"/>
+            <a:ext cx="10543032" cy="274320"/>
           </a:xfrm>
           <a:prstGeom prst="rect">
             <a:avLst/>
@@ -3418,30 +3475,92 @@
               <a:buNone/>
             </a:pPr>
             <a:r>
-              <a:rPr lang="en-US" sz="5000" b="1" dirty="0">
-                <a:solidFill>
-                  <a:srgbClr val="000000"/>
-                </a:solidFill>
-                <a:latin typeface="Calibri" pitchFamily="34" charset="0"/>
-                <a:ea typeface="Calibri" pitchFamily="34" charset="-122"/>
-                <a:cs typeface="Calibri" pitchFamily="34" charset="-120"/>
+              <a:rPr lang="en-US" sz="1200" b="1" spc="250" kern="0" dirty="0">
+                <a:solidFill>
+                  <a:srgbClr val="9A9A9A"/>
+                </a:solidFill>
+                <a:latin typeface="Avenir Next" pitchFamily="34" charset="0"/>
+                <a:ea typeface="Avenir Next" pitchFamily="34" charset="-122"/>
+                <a:cs typeface="Avenir Next" pitchFamily="34" charset="-120"/>
+              </a:rPr>
+              <a:t>GETTING STARTED</a:t>
+            </a:r>
+            <a:endParaRPr lang="en-US" sz="1200" dirty="0"/>
+          </a:p>
+        </p:txBody>
+      </p:sp>
+      <p:sp>
+        <p:nvSpPr>
+          <p:cNvPr id="3" name="Shape 1"/>
+          <p:cNvSpPr/>
+          <p:nvPr/>
+        </p:nvSpPr>
+        <p:spPr>
+          <a:xfrm>
+            <a:off x="822960" y="969264"/>
+            <a:ext cx="566928" cy="41148"/>
+          </a:xfrm>
+          <a:prstGeom prst="rect">
+            <a:avLst/>
+          </a:prstGeom>
+          <a:solidFill>
+            <a:srgbClr val="2E7A72"/>
+          </a:solidFill>
+          <a:ln/>
+        </p:spPr>
+      </p:sp>
+      <p:sp>
+        <p:nvSpPr>
+          <p:cNvPr id="4" name="Text 2"/>
+          <p:cNvSpPr/>
+          <p:nvPr/>
+        </p:nvSpPr>
+        <p:spPr>
+          <a:xfrm>
+            <a:off x="822960" y="1161288"/>
+            <a:ext cx="10543032" cy="1188720"/>
+          </a:xfrm>
+          <a:prstGeom prst="rect">
+            <a:avLst/>
+          </a:prstGeom>
+          <a:noFill/>
+          <a:ln/>
+        </p:spPr>
+        <p:txBody>
+          <a:bodyPr wrap="square" lIns="0" tIns="0" rIns="0" bIns="0" rtlCol="0" anchor="t"/>
+          <a:lstStyle/>
+          <a:p>
+            <a:pPr algn="l" indent="0" marL="0">
+              <a:lnSpc>
+                <a:spcPct val="98000"/>
+              </a:lnSpc>
+              <a:buNone/>
+            </a:pPr>
+            <a:r>
+              <a:rPr lang="en-US" sz="4000" b="1" dirty="0">
+                <a:solidFill>
+                  <a:srgbClr val="111111"/>
+                </a:solidFill>
+                <a:latin typeface="Avenir Next" pitchFamily="34" charset="0"/>
+                <a:ea typeface="Avenir Next" pitchFamily="34" charset="-122"/>
+                <a:cs typeface="Avenir Next" pitchFamily="34" charset="-120"/>
               </a:rPr>
               <a:t>How you start - Monday morning</a:t>
             </a:r>
-            <a:endParaRPr lang="en-US" sz="5000" dirty="0"/>
-          </a:p>
-        </p:txBody>
-      </p:sp>
-      <p:sp>
-        <p:nvSpPr>
-          <p:cNvPr id="4" name="Text 1"/>
-          <p:cNvSpPr/>
-          <p:nvPr/>
-        </p:nvSpPr>
-        <p:spPr>
-          <a:xfrm>
-            <a:off x="548640" y="1920240"/>
-            <a:ext cx="11091672" cy="4297680"/>
+            <a:endParaRPr lang="en-US" sz="4000" dirty="0"/>
+          </a:p>
+        </p:txBody>
+      </p:sp>
+      <p:sp>
+        <p:nvSpPr>
+          <p:cNvPr id="5" name="Text 3"/>
+          <p:cNvSpPr/>
+          <p:nvPr/>
+        </p:nvSpPr>
+        <p:spPr>
+          <a:xfrm>
+            <a:off x="822960" y="2441448"/>
+            <a:ext cx="10543032" cy="3959352"/>
           </a:xfrm>
           <a:prstGeom prst="rect">
             <a:avLst/>
@@ -3455,106 +3574,106 @@
           <a:p>
             <a:pPr algn="l" indent="0" marL="0">
               <a:lnSpc>
-                <a:spcPct val="110000"/>
+                <a:spcPct val="115000"/>
               </a:lnSpc>
               <a:spcAft>
-                <a:spcPts val="1800"/>
+                <a:spcPts val="1600"/>
               </a:spcAft>
               <a:buNone/>
             </a:pPr>
             <a:r>
-              <a:rPr lang="en-US" sz="2800" dirty="0">
-                <a:solidFill>
-                  <a:srgbClr val="0070C0"/>
-                </a:solidFill>
-                <a:latin typeface="Calibri" pitchFamily="34" charset="0"/>
-                <a:ea typeface="Calibri" pitchFamily="34" charset="-122"/>
-                <a:cs typeface="Calibri" pitchFamily="34" charset="-120"/>
+              <a:rPr lang="en-US" sz="2000" dirty="0">
+                <a:solidFill>
+                  <a:srgbClr val="2E7A72"/>
+                </a:solidFill>
+                <a:latin typeface="Avenir Next" pitchFamily="34" charset="0"/>
+                <a:ea typeface="Avenir Next" pitchFamily="34" charset="-122"/>
+                <a:cs typeface="Avenir Next" pitchFamily="34" charset="-120"/>
               </a:rPr>
               <a:t>Open Claude Code. Type what you wish existed.</a:t>
             </a:r>
-            <a:endParaRPr lang="en-US" sz="2800" dirty="0"/>
+            <a:endParaRPr lang="en-US" sz="2000" dirty="0"/>
           </a:p>
           <a:p>
             <a:pPr algn="l" indent="0" marL="0">
               <a:lnSpc>
-                <a:spcPct val="110000"/>
+                <a:spcPct val="115000"/>
               </a:lnSpc>
               <a:spcAft>
-                <a:spcPts val="1800"/>
+                <a:spcPts val="1600"/>
               </a:spcAft>
               <a:buNone/>
             </a:pPr>
             <a:r>
-              <a:rPr lang="en-US" sz="2800" dirty="0">
-                <a:solidFill>
-                  <a:srgbClr val="000000"/>
-                </a:solidFill>
-                <a:latin typeface="Calibri" pitchFamily="34" charset="0"/>
-                <a:ea typeface="Calibri" pitchFamily="34" charset="-122"/>
-                <a:cs typeface="Calibri" pitchFamily="34" charset="-120"/>
+              <a:rPr lang="en-US" sz="2000" dirty="0">
+                <a:solidFill>
+                  <a:srgbClr val="111111"/>
+                </a:solidFill>
+                <a:latin typeface="Avenir Next" pitchFamily="34" charset="0"/>
+                <a:ea typeface="Avenir Next" pitchFamily="34" charset="-122"/>
+                <a:cs typeface="Avenir Next" pitchFamily="34" charset="-120"/>
               </a:rPr>
               <a:t>Start tiny: a checklist, a tracker, a page.</a:t>
             </a:r>
-            <a:endParaRPr lang="en-US" sz="2800" dirty="0"/>
+            <a:endParaRPr lang="en-US" sz="2000" dirty="0"/>
           </a:p>
           <a:p>
             <a:pPr algn="l" indent="0" marL="0">
               <a:lnSpc>
-                <a:spcPct val="110000"/>
+                <a:spcPct val="115000"/>
               </a:lnSpc>
               <a:spcAft>
-                <a:spcPts val="1800"/>
+                <a:spcPts val="1600"/>
               </a:spcAft>
               <a:buNone/>
             </a:pPr>
             <a:r>
-              <a:rPr lang="en-US" sz="2800" dirty="0">
-                <a:solidFill>
-                  <a:srgbClr val="000000"/>
-                </a:solidFill>
-                <a:latin typeface="Calibri" pitchFamily="34" charset="0"/>
-                <a:ea typeface="Calibri" pitchFamily="34" charset="-122"/>
-                <a:cs typeface="Calibri" pitchFamily="34" charset="-120"/>
+              <a:rPr lang="en-US" sz="2000" dirty="0">
+                <a:solidFill>
+                  <a:srgbClr val="111111"/>
+                </a:solidFill>
+                <a:latin typeface="Avenir Next" pitchFamily="34" charset="0"/>
+                <a:ea typeface="Avenir Next" pitchFamily="34" charset="-122"/>
+                <a:cs typeface="Avenir Next" pitchFamily="34" charset="-120"/>
               </a:rPr>
               <a:t>When it's not quite right, tell it - in plain words.</a:t>
             </a:r>
-            <a:endParaRPr lang="en-US" sz="2800" dirty="0"/>
+            <a:endParaRPr lang="en-US" sz="2000" dirty="0"/>
           </a:p>
           <a:p>
             <a:pPr algn="l" indent="0" marL="0">
               <a:lnSpc>
-                <a:spcPct val="110000"/>
+                <a:spcPct val="115000"/>
               </a:lnSpc>
               <a:spcAft>
-                <a:spcPts val="1800"/>
+                <a:spcPts val="1600"/>
               </a:spcAft>
               <a:buNone/>
             </a:pPr>
-            <a:endParaRPr lang="en-US" sz="2800" dirty="0"/>
+            <a:endParaRPr lang="en-US" sz="2000" dirty="0"/>
           </a:p>
           <a:p>
             <a:pPr algn="l" indent="0" marL="0">
               <a:lnSpc>
-                <a:spcPct val="110000"/>
+                <a:spcPct val="115000"/>
               </a:lnSpc>
               <a:spcAft>
-                <a:spcPts val="1800"/>
+                <a:spcPts val="1600"/>
               </a:spcAft>
               <a:buNone/>
             </a:pPr>
             <a:r>
-              <a:rPr lang="en-US" sz="2800" dirty="0">
-                <a:solidFill>
-                  <a:srgbClr val="800000"/>
-                </a:solidFill>
-                <a:latin typeface="Calibri" pitchFamily="34" charset="0"/>
-                <a:ea typeface="Calibri" pitchFamily="34" charset="-122"/>
-                <a:cs typeface="Calibri" pitchFamily="34" charset="-120"/>
+              <a:rPr lang="en-US" sz="2000" b="1" dirty="0">
+                <a:solidFill>
+                  <a:srgbClr val="111111"/>
+                </a:solidFill>
+                <a:latin typeface="Avenir Next" pitchFamily="34" charset="0"/>
+                <a:ea typeface="Avenir Next" pitchFamily="34" charset="-122"/>
+                <a:cs typeface="Avenir Next" pitchFamily="34" charset="-120"/>
               </a:rPr>
               <a:t>The only skill required is describing what you want.</a:t>
             </a:r>
-            <a:endParaRPr lang="en-US" sz="2800" dirty="0"/>
+            <a:endParaRPr lang="en-US" sz="2000" dirty="0"/>
           </a:p>
         </p:txBody>
       </p:sp>
@@ -3583,40 +3702,16 @@
           <a:chExt cx="0" cy="0"/>
         </a:xfrm>
       </p:grpSpPr>
-      <p:pic>
-        <p:nvPicPr>
-          <p:cNvPr id="2" name="Image 0" descr="/Users/batuhangundogdu/Claude Code Workshop/deck/assets/uchicago-footer.png">    </p:cNvPr>
-          <p:cNvPicPr>
-            <a:picLocks noChangeAspect="1"/>
-          </p:cNvPicPr>
-          <p:nvPr/>
-        </p:nvPicPr>
-        <p:blipFill>
-          <a:blip r:embed="rId1"/>
-          <a:stretch>
-            <a:fillRect/>
-          </a:stretch>
-        </p:blipFill>
-        <p:spPr>
-          <a:xfrm>
-            <a:off x="539496" y="6382512"/>
-            <a:ext cx="2843784" cy="475488"/>
-          </a:xfrm>
-          <a:prstGeom prst="rect">
-            <a:avLst/>
-          </a:prstGeom>
-        </p:spPr>
-      </p:pic>
-      <p:sp>
-        <p:nvSpPr>
-          <p:cNvPr id="3" name="Text 0"/>
-          <p:cNvSpPr/>
-          <p:nvPr/>
-        </p:nvSpPr>
-        <p:spPr>
-          <a:xfrm>
-            <a:off x="548640" y="365760"/>
-            <a:ext cx="11091672" cy="1188720"/>
+      <p:sp>
+        <p:nvSpPr>
+          <p:cNvPr id="2" name="Text 0"/>
+          <p:cNvSpPr/>
+          <p:nvPr/>
+        </p:nvSpPr>
+        <p:spPr>
+          <a:xfrm>
+            <a:off x="822960" y="658368"/>
+            <a:ext cx="10543032" cy="274320"/>
           </a:xfrm>
           <a:prstGeom prst="rect">
             <a:avLst/>
@@ -3632,30 +3727,92 @@
               <a:buNone/>
             </a:pPr>
             <a:r>
-              <a:rPr lang="en-US" sz="5000" b="1" dirty="0">
-                <a:solidFill>
-                  <a:srgbClr val="000000"/>
-                </a:solidFill>
-                <a:latin typeface="Calibri" pitchFamily="34" charset="0"/>
-                <a:ea typeface="Calibri" pitchFamily="34" charset="-122"/>
-                <a:cs typeface="Calibri" pitchFamily="34" charset="-120"/>
+              <a:rPr lang="en-US" sz="1200" b="1" spc="250" kern="0" dirty="0">
+                <a:solidFill>
+                  <a:srgbClr val="9A9A9A"/>
+                </a:solidFill>
+                <a:latin typeface="Avenir Next" pitchFamily="34" charset="0"/>
+                <a:ea typeface="Avenir Next" pitchFamily="34" charset="-122"/>
+                <a:cs typeface="Avenir Next" pitchFamily="34" charset="-120"/>
+              </a:rPr>
+              <a:t>YOUR TURN</a:t>
+            </a:r>
+            <a:endParaRPr lang="en-US" sz="1200" dirty="0"/>
+          </a:p>
+        </p:txBody>
+      </p:sp>
+      <p:sp>
+        <p:nvSpPr>
+          <p:cNvPr id="3" name="Shape 1"/>
+          <p:cNvSpPr/>
+          <p:nvPr/>
+        </p:nvSpPr>
+        <p:spPr>
+          <a:xfrm>
+            <a:off x="822960" y="969264"/>
+            <a:ext cx="566928" cy="41148"/>
+          </a:xfrm>
+          <a:prstGeom prst="rect">
+            <a:avLst/>
+          </a:prstGeom>
+          <a:solidFill>
+            <a:srgbClr val="2E7A72"/>
+          </a:solidFill>
+          <a:ln/>
+        </p:spPr>
+      </p:sp>
+      <p:sp>
+        <p:nvSpPr>
+          <p:cNvPr id="4" name="Text 2"/>
+          <p:cNvSpPr/>
+          <p:nvPr/>
+        </p:nvSpPr>
+        <p:spPr>
+          <a:xfrm>
+            <a:off x="822960" y="1161288"/>
+            <a:ext cx="10543032" cy="1188720"/>
+          </a:xfrm>
+          <a:prstGeom prst="rect">
+            <a:avLst/>
+          </a:prstGeom>
+          <a:noFill/>
+          <a:ln/>
+        </p:spPr>
+        <p:txBody>
+          <a:bodyPr wrap="square" lIns="0" tIns="0" rIns="0" bIns="0" rtlCol="0" anchor="t"/>
+          <a:lstStyle/>
+          <a:p>
+            <a:pPr algn="l" indent="0" marL="0">
+              <a:lnSpc>
+                <a:spcPct val="98000"/>
+              </a:lnSpc>
+              <a:buNone/>
+            </a:pPr>
+            <a:r>
+              <a:rPr lang="en-US" sz="4000" b="1" dirty="0">
+                <a:solidFill>
+                  <a:srgbClr val="111111"/>
+                </a:solidFill>
+                <a:latin typeface="Avenir Next" pitchFamily="34" charset="0"/>
+                <a:ea typeface="Avenir Next" pitchFamily="34" charset="-122"/>
+                <a:cs typeface="Avenir Next" pitchFamily="34" charset="-120"/>
               </a:rPr>
               <a:t>Your turn</a:t>
             </a:r>
-            <a:endParaRPr lang="en-US" sz="5000" dirty="0"/>
-          </a:p>
-        </p:txBody>
-      </p:sp>
-      <p:sp>
-        <p:nvSpPr>
-          <p:cNvPr id="4" name="Text 1"/>
-          <p:cNvSpPr/>
-          <p:nvPr/>
-        </p:nvSpPr>
-        <p:spPr>
-          <a:xfrm>
-            <a:off x="548640" y="1920240"/>
-            <a:ext cx="11091672" cy="4297680"/>
+            <a:endParaRPr lang="en-US" sz="4000" dirty="0"/>
+          </a:p>
+        </p:txBody>
+      </p:sp>
+      <p:sp>
+        <p:nvSpPr>
+          <p:cNvPr id="5" name="Text 3"/>
+          <p:cNvSpPr/>
+          <p:nvPr/>
+        </p:nvSpPr>
+        <p:spPr>
+          <a:xfrm>
+            <a:off x="822960" y="2441448"/>
+            <a:ext cx="10543032" cy="3959352"/>
           </a:xfrm>
           <a:prstGeom prst="rect">
             <a:avLst/>
@@ -3669,83 +3826,83 @@
           <a:p>
             <a:pPr algn="l" indent="0" marL="0">
               <a:lnSpc>
-                <a:spcPct val="110000"/>
+                <a:spcPct val="115000"/>
               </a:lnSpc>
               <a:spcAft>
-                <a:spcPts val="1800"/>
+                <a:spcPts val="1600"/>
               </a:spcAft>
               <a:buNone/>
             </a:pPr>
             <a:r>
-              <a:rPr lang="en-US" sz="2800" dirty="0">
-                <a:solidFill>
-                  <a:srgbClr val="0070C0"/>
-                </a:solidFill>
-                <a:latin typeface="Calibri" pitchFamily="34" charset="0"/>
-                <a:ea typeface="Calibri" pitchFamily="34" charset="-122"/>
-                <a:cs typeface="Calibri" pitchFamily="34" charset="-120"/>
+              <a:rPr lang="en-US" sz="2000" dirty="0">
+                <a:solidFill>
+                  <a:srgbClr val="2E7A72"/>
+                </a:solidFill>
+                <a:latin typeface="Avenir Next" pitchFamily="34" charset="0"/>
+                <a:ea typeface="Avenir Next" pitchFamily="34" charset="-122"/>
+                <a:cs typeface="Avenir Next" pitchFamily="34" charset="-120"/>
               </a:rPr>
               <a:t>Open Claude Code. Describe the thing you wish existed.</a:t>
             </a:r>
-            <a:endParaRPr lang="en-US" sz="2800" dirty="0"/>
+            <a:endParaRPr lang="en-US" sz="2000" dirty="0"/>
           </a:p>
           <a:p>
             <a:pPr algn="l" indent="0" marL="0">
               <a:lnSpc>
-                <a:spcPct val="110000"/>
+                <a:spcPct val="115000"/>
               </a:lnSpc>
               <a:spcAft>
-                <a:spcPts val="1800"/>
+                <a:spcPts val="1600"/>
               </a:spcAft>
               <a:buNone/>
             </a:pPr>
             <a:r>
-              <a:rPr lang="en-US" sz="2800" dirty="0">
-                <a:solidFill>
-                  <a:srgbClr val="000000"/>
-                </a:solidFill>
-                <a:latin typeface="Calibri" pitchFamily="34" charset="0"/>
-                <a:ea typeface="Calibri" pitchFamily="34" charset="-122"/>
-                <a:cs typeface="Calibri" pitchFamily="34" charset="-120"/>
+              <a:rPr lang="en-US" sz="2000" dirty="0">
+                <a:solidFill>
+                  <a:srgbClr val="111111"/>
+                </a:solidFill>
+                <a:latin typeface="Avenir Next" pitchFamily="34" charset="0"/>
+                <a:ea typeface="Avenir Next" pitchFamily="34" charset="-122"/>
+                <a:cs typeface="Avenir Next" pitchFamily="34" charset="-120"/>
               </a:rPr>
               <a:t>You just watched me do it - no code, no template.</a:t>
             </a:r>
-            <a:endParaRPr lang="en-US" sz="2800" dirty="0"/>
+            <a:endParaRPr lang="en-US" sz="2000" dirty="0"/>
           </a:p>
           <a:p>
             <a:pPr algn="l" indent="0" marL="0">
               <a:lnSpc>
-                <a:spcPct val="110000"/>
+                <a:spcPct val="115000"/>
               </a:lnSpc>
               <a:spcAft>
-                <a:spcPts val="1800"/>
+                <a:spcPts val="1600"/>
               </a:spcAft>
               <a:buNone/>
             </a:pPr>
-            <a:endParaRPr lang="en-US" sz="2800" dirty="0"/>
+            <a:endParaRPr lang="en-US" sz="2000" dirty="0"/>
           </a:p>
           <a:p>
             <a:pPr algn="l" indent="0" marL="0">
               <a:lnSpc>
-                <a:spcPct val="110000"/>
+                <a:spcPct val="115000"/>
               </a:lnSpc>
               <a:spcAft>
-                <a:spcPts val="1800"/>
+                <a:spcPts val="1600"/>
               </a:spcAft>
               <a:buNone/>
             </a:pPr>
             <a:r>
-              <a:rPr lang="en-US" sz="2800" dirty="0">
-                <a:solidFill>
-                  <a:srgbClr val="00B050"/>
-                </a:solidFill>
-                <a:latin typeface="Calibri" pitchFamily="34" charset="0"/>
-                <a:ea typeface="Calibri" pitchFamily="34" charset="-122"/>
-                <a:cs typeface="Calibri" pitchFamily="34" charset="-120"/>
+              <a:rPr lang="en-US" sz="2000" dirty="0">
+                <a:solidFill>
+                  <a:srgbClr val="2E7A72"/>
+                </a:solidFill>
+                <a:latin typeface="Avenir Next" pitchFamily="34" charset="0"/>
+                <a:ea typeface="Avenir Next" pitchFamily="34" charset="-122"/>
+                <a:cs typeface="Avenir Next" pitchFamily="34" charset="-120"/>
               </a:rPr>
               <a:t>Go build something you wished existed.</a:t>
             </a:r>
-            <a:endParaRPr lang="en-US" sz="2800" dirty="0"/>
+            <a:endParaRPr lang="en-US" sz="2000" dirty="0"/>
           </a:p>
         </p:txBody>
       </p:sp>
@@ -3774,40 +3931,16 @@
           <a:chExt cx="0" cy="0"/>
         </a:xfrm>
       </p:grpSpPr>
-      <p:pic>
-        <p:nvPicPr>
-          <p:cNvPr id="2" name="Image 0" descr="/Users/batuhangundogdu/Claude Code Workshop/deck/assets/uchicago-footer.png">    </p:cNvPr>
-          <p:cNvPicPr>
-            <a:picLocks noChangeAspect="1"/>
-          </p:cNvPicPr>
-          <p:nvPr/>
-        </p:nvPicPr>
-        <p:blipFill>
-          <a:blip r:embed="rId1"/>
-          <a:stretch>
-            <a:fillRect/>
-          </a:stretch>
-        </p:blipFill>
-        <p:spPr>
-          <a:xfrm>
-            <a:off x="539496" y="6382512"/>
-            <a:ext cx="2843784" cy="475488"/>
-          </a:xfrm>
-          <a:prstGeom prst="rect">
-            <a:avLst/>
-          </a:prstGeom>
-        </p:spPr>
-      </p:pic>
-      <p:sp>
-        <p:nvSpPr>
-          <p:cNvPr id="3" name="Text 0"/>
-          <p:cNvSpPr/>
-          <p:nvPr/>
-        </p:nvSpPr>
-        <p:spPr>
-          <a:xfrm>
-            <a:off x="548640" y="365760"/>
-            <a:ext cx="11091672" cy="1188720"/>
+      <p:sp>
+        <p:nvSpPr>
+          <p:cNvPr id="2" name="Text 0"/>
+          <p:cNvSpPr/>
+          <p:nvPr/>
+        </p:nvSpPr>
+        <p:spPr>
+          <a:xfrm>
+            <a:off x="822960" y="658368"/>
+            <a:ext cx="10543032" cy="274320"/>
           </a:xfrm>
           <a:prstGeom prst="rect">
             <a:avLst/>
@@ -3823,30 +3956,92 @@
               <a:buNone/>
             </a:pPr>
             <a:r>
-              <a:rPr lang="en-US" sz="5000" b="1" dirty="0">
-                <a:solidFill>
-                  <a:srgbClr val="000000"/>
-                </a:solidFill>
-                <a:latin typeface="Calibri" pitchFamily="34" charset="0"/>
-                <a:ea typeface="Calibri" pitchFamily="34" charset="-122"/>
-                <a:cs typeface="Calibri" pitchFamily="34" charset="-120"/>
+              <a:rPr lang="en-US" sz="1200" b="1" spc="250" kern="0" dirty="0">
+                <a:solidFill>
+                  <a:srgbClr val="9A9A9A"/>
+                </a:solidFill>
+                <a:latin typeface="Avenir Next" pitchFamily="34" charset="0"/>
+                <a:ea typeface="Avenir Next" pitchFamily="34" charset="-122"/>
+                <a:cs typeface="Avenir Next" pitchFamily="34" charset="-120"/>
+              </a:rPr>
+              <a:t>WARM-UP POLL</a:t>
+            </a:r>
+            <a:endParaRPr lang="en-US" sz="1200" dirty="0"/>
+          </a:p>
+        </p:txBody>
+      </p:sp>
+      <p:sp>
+        <p:nvSpPr>
+          <p:cNvPr id="3" name="Shape 1"/>
+          <p:cNvSpPr/>
+          <p:nvPr/>
+        </p:nvSpPr>
+        <p:spPr>
+          <a:xfrm>
+            <a:off x="822960" y="969264"/>
+            <a:ext cx="566928" cy="41148"/>
+          </a:xfrm>
+          <a:prstGeom prst="rect">
+            <a:avLst/>
+          </a:prstGeom>
+          <a:solidFill>
+            <a:srgbClr val="2E7A72"/>
+          </a:solidFill>
+          <a:ln/>
+        </p:spPr>
+      </p:sp>
+      <p:sp>
+        <p:nvSpPr>
+          <p:cNvPr id="4" name="Text 2"/>
+          <p:cNvSpPr/>
+          <p:nvPr/>
+        </p:nvSpPr>
+        <p:spPr>
+          <a:xfrm>
+            <a:off x="822960" y="1161288"/>
+            <a:ext cx="10543032" cy="1188720"/>
+          </a:xfrm>
+          <a:prstGeom prst="rect">
+            <a:avLst/>
+          </a:prstGeom>
+          <a:noFill/>
+          <a:ln/>
+        </p:spPr>
+        <p:txBody>
+          <a:bodyPr wrap="square" lIns="0" tIns="0" rIns="0" bIns="0" rtlCol="0" anchor="t"/>
+          <a:lstStyle/>
+          <a:p>
+            <a:pPr algn="l" indent="0" marL="0">
+              <a:lnSpc>
+                <a:spcPct val="98000"/>
+              </a:lnSpc>
+              <a:buNone/>
+            </a:pPr>
+            <a:r>
+              <a:rPr lang="en-US" sz="4000" b="1" dirty="0">
+                <a:solidFill>
+                  <a:srgbClr val="111111"/>
+                </a:solidFill>
+                <a:latin typeface="Avenir Next" pitchFamily="34" charset="0"/>
+                <a:ea typeface="Avenir Next" pitchFamily="34" charset="-122"/>
+                <a:cs typeface="Avenir Next" pitchFamily="34" charset="-120"/>
               </a:rPr>
               <a:t>First - who's in the room?</a:t>
             </a:r>
-            <a:endParaRPr lang="en-US" sz="5000" dirty="0"/>
-          </a:p>
-        </p:txBody>
-      </p:sp>
-      <p:sp>
-        <p:nvSpPr>
-          <p:cNvPr id="4" name="Text 1"/>
-          <p:cNvSpPr/>
-          <p:nvPr/>
-        </p:nvSpPr>
-        <p:spPr>
-          <a:xfrm>
-            <a:off x="548640" y="1920240"/>
-            <a:ext cx="11091672" cy="4297680"/>
+            <a:endParaRPr lang="en-US" sz="4000" dirty="0"/>
+          </a:p>
+        </p:txBody>
+      </p:sp>
+      <p:sp>
+        <p:nvSpPr>
+          <p:cNvPr id="5" name="Text 3"/>
+          <p:cNvSpPr/>
+          <p:nvPr/>
+        </p:nvSpPr>
+        <p:spPr>
+          <a:xfrm>
+            <a:off x="822960" y="2441448"/>
+            <a:ext cx="10543032" cy="3959352"/>
           </a:xfrm>
           <a:prstGeom prst="rect">
             <a:avLst/>
@@ -3860,106 +4055,106 @@
           <a:p>
             <a:pPr algn="l" indent="0" marL="0">
               <a:lnSpc>
-                <a:spcPct val="110000"/>
+                <a:spcPct val="115000"/>
               </a:lnSpc>
               <a:spcAft>
-                <a:spcPts val="1800"/>
+                <a:spcPts val="1600"/>
               </a:spcAft>
               <a:buNone/>
             </a:pPr>
             <a:r>
-              <a:rPr lang="en-US" sz="2800" dirty="0">
-                <a:solidFill>
-                  <a:srgbClr val="800000"/>
-                </a:solidFill>
-                <a:latin typeface="Calibri" pitchFamily="34" charset="0"/>
-                <a:ea typeface="Calibri" pitchFamily="34" charset="-122"/>
-                <a:cs typeface="Calibri" pitchFamily="34" charset="-120"/>
+              <a:rPr lang="en-US" sz="2000" b="1" dirty="0">
+                <a:solidFill>
+                  <a:srgbClr val="111111"/>
+                </a:solidFill>
+                <a:latin typeface="Avenir Next" pitchFamily="34" charset="0"/>
+                <a:ea typeface="Avenir Next" pitchFamily="34" charset="-122"/>
+                <a:cs typeface="Avenir Next" pitchFamily="34" charset="-120"/>
               </a:rPr>
               <a:t>Scan the QR and pick one.  [ Poll Everywhere QR - top right ]</a:t>
             </a:r>
-            <a:endParaRPr lang="en-US" sz="2800" dirty="0"/>
+            <a:endParaRPr lang="en-US" sz="2000" dirty="0"/>
           </a:p>
           <a:p>
             <a:pPr algn="l" indent="0" marL="0">
               <a:lnSpc>
-                <a:spcPct val="110000"/>
+                <a:spcPct val="115000"/>
               </a:lnSpc>
               <a:spcAft>
-                <a:spcPts val="1800"/>
+                <a:spcPts val="1600"/>
               </a:spcAft>
               <a:buNone/>
             </a:pPr>
-            <a:endParaRPr lang="en-US" sz="2800" dirty="0"/>
+            <a:endParaRPr lang="en-US" sz="2000" dirty="0"/>
           </a:p>
           <a:p>
             <a:pPr algn="l" indent="0" marL="0">
               <a:lnSpc>
-                <a:spcPct val="110000"/>
+                <a:spcPct val="115000"/>
               </a:lnSpc>
               <a:spcAft>
-                <a:spcPts val="1800"/>
+                <a:spcPts val="1600"/>
               </a:spcAft>
               <a:buNone/>
             </a:pPr>
             <a:r>
-              <a:rPr lang="en-US" sz="2800" dirty="0">
-                <a:solidFill>
-                  <a:srgbClr val="00B050"/>
-                </a:solidFill>
-                <a:latin typeface="Calibri" pitchFamily="34" charset="0"/>
-                <a:ea typeface="Calibri" pitchFamily="34" charset="-122"/>
-                <a:cs typeface="Calibri" pitchFamily="34" charset="-120"/>
+              <a:rPr lang="en-US" sz="2000" dirty="0">
+                <a:solidFill>
+                  <a:srgbClr val="2E7A72"/>
+                </a:solidFill>
+                <a:latin typeface="Avenir Next" pitchFamily="34" charset="0"/>
+                <a:ea typeface="Avenir Next" pitchFamily="34" charset="-122"/>
+                <a:cs typeface="Avenir Next" pitchFamily="34" charset="-120"/>
               </a:rPr>
               <a:t>1 · I already use it every day - here to see what else it can do.</a:t>
             </a:r>
-            <a:endParaRPr lang="en-US" sz="2800" dirty="0"/>
+            <a:endParaRPr lang="en-US" sz="2000" dirty="0"/>
           </a:p>
           <a:p>
             <a:pPr algn="l" indent="0" marL="0">
               <a:lnSpc>
-                <a:spcPct val="110000"/>
+                <a:spcPct val="115000"/>
               </a:lnSpc>
               <a:spcAft>
-                <a:spcPts val="1800"/>
+                <a:spcPts val="1600"/>
               </a:spcAft>
               <a:buNone/>
             </a:pPr>
             <a:r>
-              <a:rPr lang="en-US" sz="2800" dirty="0">
-                <a:solidFill>
-                  <a:srgbClr val="0070C0"/>
-                </a:solidFill>
-                <a:latin typeface="Calibri" pitchFamily="34" charset="0"/>
-                <a:ea typeface="Calibri" pitchFamily="34" charset="-122"/>
-                <a:cs typeface="Calibri" pitchFamily="34" charset="-120"/>
+              <a:rPr lang="en-US" sz="2000" dirty="0">
+                <a:solidFill>
+                  <a:srgbClr val="2E7A72"/>
+                </a:solidFill>
+                <a:latin typeface="Avenir Next" pitchFamily="34" charset="0"/>
+                <a:ea typeface="Avenir Next" pitchFamily="34" charset="-122"/>
+                <a:cs typeface="Avenir Next" pitchFamily="34" charset="-120"/>
               </a:rPr>
               <a:t>2 · I don't know much - having my FOMO right now.</a:t>
             </a:r>
-            <a:endParaRPr lang="en-US" sz="2800" dirty="0"/>
+            <a:endParaRPr lang="en-US" sz="2000" dirty="0"/>
           </a:p>
           <a:p>
             <a:pPr algn="l" indent="0" marL="0">
               <a:lnSpc>
-                <a:spcPct val="110000"/>
+                <a:spcPct val="115000"/>
               </a:lnSpc>
               <a:spcAft>
-                <a:spcPts val="1800"/>
+                <a:spcPts val="1600"/>
               </a:spcAft>
               <a:buNone/>
             </a:pPr>
             <a:r>
-              <a:rPr lang="en-US" sz="2800" dirty="0">
-                <a:solidFill>
-                  <a:srgbClr val="000000"/>
-                </a:solidFill>
-                <a:latin typeface="Calibri" pitchFamily="34" charset="0"/>
-                <a:ea typeface="Calibri" pitchFamily="34" charset="-122"/>
-                <a:cs typeface="Calibri" pitchFamily="34" charset="-120"/>
+              <a:rPr lang="en-US" sz="2000" dirty="0">
+                <a:solidFill>
+                  <a:srgbClr val="111111"/>
+                </a:solidFill>
+                <a:latin typeface="Avenir Next" pitchFamily="34" charset="0"/>
+                <a:ea typeface="Avenir Next" pitchFamily="34" charset="-122"/>
+                <a:cs typeface="Avenir Next" pitchFamily="34" charset="-120"/>
               </a:rPr>
               <a:t>3 · I'm a skeptic - don't think much of it, but here I am anyway.</a:t>
             </a:r>
-            <a:endParaRPr lang="en-US" sz="2800" dirty="0"/>
+            <a:endParaRPr lang="en-US" sz="2000" dirty="0"/>
           </a:p>
         </p:txBody>
       </p:sp>
@@ -3988,40 +4183,16 @@
           <a:chExt cx="0" cy="0"/>
         </a:xfrm>
       </p:grpSpPr>
-      <p:pic>
-        <p:nvPicPr>
-          <p:cNvPr id="2" name="Image 0" descr="/Users/batuhangundogdu/Claude Code Workshop/deck/assets/uchicago-footer.png">    </p:cNvPr>
-          <p:cNvPicPr>
-            <a:picLocks noChangeAspect="1"/>
-          </p:cNvPicPr>
-          <p:nvPr/>
-        </p:nvPicPr>
-        <p:blipFill>
-          <a:blip r:embed="rId1"/>
-          <a:stretch>
-            <a:fillRect/>
-          </a:stretch>
-        </p:blipFill>
-        <p:spPr>
-          <a:xfrm>
-            <a:off x="539496" y="6382512"/>
-            <a:ext cx="2843784" cy="475488"/>
-          </a:xfrm>
-          <a:prstGeom prst="rect">
-            <a:avLst/>
-          </a:prstGeom>
-        </p:spPr>
-      </p:pic>
-      <p:sp>
-        <p:nvSpPr>
-          <p:cNvPr id="3" name="Text 0"/>
-          <p:cNvSpPr/>
-          <p:nvPr/>
-        </p:nvSpPr>
-        <p:spPr>
-          <a:xfrm>
-            <a:off x="548640" y="2468880"/>
-            <a:ext cx="11091672" cy="457200"/>
+      <p:sp>
+        <p:nvSpPr>
+          <p:cNvPr id="2" name="Text 0"/>
+          <p:cNvSpPr/>
+          <p:nvPr/>
+        </p:nvSpPr>
+        <p:spPr>
+          <a:xfrm>
+            <a:off x="822960" y="2514600"/>
+            <a:ext cx="10543032" cy="365760"/>
           </a:xfrm>
           <a:prstGeom prst="rect">
             <a:avLst/>
@@ -4037,30 +4208,50 @@
               <a:buNone/>
             </a:pPr>
             <a:r>
-              <a:rPr lang="en-US" sz="2400" spc="200" kern="0" dirty="0">
-                <a:solidFill>
-                  <a:srgbClr val="800000"/>
-                </a:solidFill>
-                <a:latin typeface="Calibri" pitchFamily="34" charset="0"/>
-                <a:ea typeface="Calibri" pitchFamily="34" charset="-122"/>
-                <a:cs typeface="Calibri" pitchFamily="34" charset="-120"/>
+              <a:rPr lang="en-US" sz="1500" b="1" spc="300" kern="0" dirty="0">
+                <a:solidFill>
+                  <a:srgbClr val="2E7A72"/>
+                </a:solidFill>
+                <a:latin typeface="Avenir Next" pitchFamily="34" charset="0"/>
+                <a:ea typeface="Avenir Next" pitchFamily="34" charset="-122"/>
+                <a:cs typeface="Avenir Next" pitchFamily="34" charset="-120"/>
               </a:rPr>
               <a:t>PART ONE</a:t>
             </a:r>
-            <a:endParaRPr lang="en-US" sz="2400" dirty="0"/>
-          </a:p>
-        </p:txBody>
-      </p:sp>
-      <p:sp>
-        <p:nvSpPr>
-          <p:cNvPr id="4" name="Text 1"/>
-          <p:cNvSpPr/>
-          <p:nvPr/>
-        </p:nvSpPr>
-        <p:spPr>
-          <a:xfrm>
-            <a:off x="548640" y="2926080"/>
-            <a:ext cx="11091672" cy="1463040"/>
+            <a:endParaRPr lang="en-US" sz="1500" dirty="0"/>
+          </a:p>
+        </p:txBody>
+      </p:sp>
+      <p:sp>
+        <p:nvSpPr>
+          <p:cNvPr id="3" name="Shape 1"/>
+          <p:cNvSpPr/>
+          <p:nvPr/>
+        </p:nvSpPr>
+        <p:spPr>
+          <a:xfrm>
+            <a:off x="822960" y="2926080"/>
+            <a:ext cx="566928" cy="41148"/>
+          </a:xfrm>
+          <a:prstGeom prst="rect">
+            <a:avLst/>
+          </a:prstGeom>
+          <a:solidFill>
+            <a:srgbClr val="2E7A72"/>
+          </a:solidFill>
+          <a:ln/>
+        </p:spPr>
+      </p:sp>
+      <p:sp>
+        <p:nvSpPr>
+          <p:cNvPr id="4" name="Text 2"/>
+          <p:cNvSpPr/>
+          <p:nvPr/>
+        </p:nvSpPr>
+        <p:spPr>
+          <a:xfrm>
+            <a:off x="822960" y="3108960"/>
+            <a:ext cx="10543032" cy="1463040"/>
           </a:xfrm>
           <a:prstGeom prst="rect">
             <a:avLst/>
@@ -4073,20 +4264,23 @@
           <a:lstStyle/>
           <a:p>
             <a:pPr algn="l" indent="0" marL="0">
-              <a:buNone/>
-            </a:pPr>
-            <a:r>
-              <a:rPr lang="en-US" sz="5000" b="1" dirty="0">
-                <a:solidFill>
-                  <a:srgbClr val="000000"/>
-                </a:solidFill>
-                <a:latin typeface="Calibri" pitchFamily="34" charset="0"/>
-                <a:ea typeface="Calibri" pitchFamily="34" charset="-122"/>
-                <a:cs typeface="Calibri" pitchFamily="34" charset="-120"/>
+              <a:lnSpc>
+                <a:spcPct val="98000"/>
+              </a:lnSpc>
+              <a:buNone/>
+            </a:pPr>
+            <a:r>
+              <a:rPr lang="en-US" sz="4400" b="1" dirty="0">
+                <a:solidFill>
+                  <a:srgbClr val="111111"/>
+                </a:solidFill>
+                <a:latin typeface="Avenir Next" pitchFamily="34" charset="0"/>
+                <a:ea typeface="Avenir Next" pitchFamily="34" charset="-122"/>
+                <a:cs typeface="Avenir Next" pitchFamily="34" charset="-120"/>
               </a:rPr>
               <a:t>The one big idea</a:t>
             </a:r>
-            <a:endParaRPr lang="en-US" sz="5000" dirty="0"/>
+            <a:endParaRPr lang="en-US" sz="4400" dirty="0"/>
           </a:p>
         </p:txBody>
       </p:sp>
@@ -4115,40 +4309,16 @@
           <a:chExt cx="0" cy="0"/>
         </a:xfrm>
       </p:grpSpPr>
-      <p:pic>
-        <p:nvPicPr>
-          <p:cNvPr id="2" name="Image 0" descr="/Users/batuhangundogdu/Claude Code Workshop/deck/assets/uchicago-footer.png">    </p:cNvPr>
-          <p:cNvPicPr>
-            <a:picLocks noChangeAspect="1"/>
-          </p:cNvPicPr>
-          <p:nvPr/>
-        </p:nvPicPr>
-        <p:blipFill>
-          <a:blip r:embed="rId1"/>
-          <a:stretch>
-            <a:fillRect/>
-          </a:stretch>
-        </p:blipFill>
-        <p:spPr>
-          <a:xfrm>
-            <a:off x="539496" y="6382512"/>
-            <a:ext cx="2843784" cy="475488"/>
-          </a:xfrm>
-          <a:prstGeom prst="rect">
-            <a:avLst/>
-          </a:prstGeom>
-        </p:spPr>
-      </p:pic>
-      <p:sp>
-        <p:nvSpPr>
-          <p:cNvPr id="3" name="Text 0"/>
-          <p:cNvSpPr/>
-          <p:nvPr/>
-        </p:nvSpPr>
-        <p:spPr>
-          <a:xfrm>
-            <a:off x="548640" y="365760"/>
-            <a:ext cx="11091672" cy="1188720"/>
+      <p:sp>
+        <p:nvSpPr>
+          <p:cNvPr id="2" name="Text 0"/>
+          <p:cNvSpPr/>
+          <p:nvPr/>
+        </p:nvSpPr>
+        <p:spPr>
+          <a:xfrm>
+            <a:off x="822960" y="658368"/>
+            <a:ext cx="10543032" cy="274320"/>
           </a:xfrm>
           <a:prstGeom prst="rect">
             <a:avLst/>
@@ -4164,30 +4334,92 @@
               <a:buNone/>
             </a:pPr>
             <a:r>
-              <a:rPr lang="en-US" sz="5000" b="1" dirty="0">
-                <a:solidFill>
-                  <a:srgbClr val="000000"/>
-                </a:solidFill>
-                <a:latin typeface="Calibri" pitchFamily="34" charset="0"/>
-                <a:ea typeface="Calibri" pitchFamily="34" charset="-122"/>
-                <a:cs typeface="Calibri" pitchFamily="34" charset="-120"/>
+              <a:rPr lang="en-US" sz="1200" b="1" spc="250" kern="0" dirty="0">
+                <a:solidFill>
+                  <a:srgbClr val="9A9A9A"/>
+                </a:solidFill>
+                <a:latin typeface="Avenir Next" pitchFamily="34" charset="0"/>
+                <a:ea typeface="Avenir Next" pitchFamily="34" charset="-122"/>
+                <a:cs typeface="Avenir Next" pitchFamily="34" charset="-120"/>
+              </a:rPr>
+              <a:t>THE BIG IDEA</a:t>
+            </a:r>
+            <a:endParaRPr lang="en-US" sz="1200" dirty="0"/>
+          </a:p>
+        </p:txBody>
+      </p:sp>
+      <p:sp>
+        <p:nvSpPr>
+          <p:cNvPr id="3" name="Shape 1"/>
+          <p:cNvSpPr/>
+          <p:nvPr/>
+        </p:nvSpPr>
+        <p:spPr>
+          <a:xfrm>
+            <a:off x="822960" y="969264"/>
+            <a:ext cx="566928" cy="41148"/>
+          </a:xfrm>
+          <a:prstGeom prst="rect">
+            <a:avLst/>
+          </a:prstGeom>
+          <a:solidFill>
+            <a:srgbClr val="2E7A72"/>
+          </a:solidFill>
+          <a:ln/>
+        </p:spPr>
+      </p:sp>
+      <p:sp>
+        <p:nvSpPr>
+          <p:cNvPr id="4" name="Text 2"/>
+          <p:cNvSpPr/>
+          <p:nvPr/>
+        </p:nvSpPr>
+        <p:spPr>
+          <a:xfrm>
+            <a:off x="822960" y="1161288"/>
+            <a:ext cx="10543032" cy="1188720"/>
+          </a:xfrm>
+          <a:prstGeom prst="rect">
+            <a:avLst/>
+          </a:prstGeom>
+          <a:noFill/>
+          <a:ln/>
+        </p:spPr>
+        <p:txBody>
+          <a:bodyPr wrap="square" lIns="0" tIns="0" rIns="0" bIns="0" rtlCol="0" anchor="t"/>
+          <a:lstStyle/>
+          <a:p>
+            <a:pPr algn="l" indent="0" marL="0">
+              <a:lnSpc>
+                <a:spcPct val="98000"/>
+              </a:lnSpc>
+              <a:buNone/>
+            </a:pPr>
+            <a:r>
+              <a:rPr lang="en-US" sz="4000" b="1" dirty="0">
+                <a:solidFill>
+                  <a:srgbClr val="111111"/>
+                </a:solidFill>
+                <a:latin typeface="Avenir Next" pitchFamily="34" charset="0"/>
+                <a:ea typeface="Avenir Next" pitchFamily="34" charset="-122"/>
+                <a:cs typeface="Avenir Next" pitchFamily="34" charset="-120"/>
               </a:rPr>
               <a:t>It's not a coding tool. It's a conversation.</a:t>
             </a:r>
-            <a:endParaRPr lang="en-US" sz="5000" dirty="0"/>
-          </a:p>
-        </p:txBody>
-      </p:sp>
-      <p:sp>
-        <p:nvSpPr>
-          <p:cNvPr id="4" name="Text 1"/>
-          <p:cNvSpPr/>
-          <p:nvPr/>
-        </p:nvSpPr>
-        <p:spPr>
-          <a:xfrm>
-            <a:off x="548640" y="1920240"/>
-            <a:ext cx="11091672" cy="4297680"/>
+            <a:endParaRPr lang="en-US" sz="4000" dirty="0"/>
+          </a:p>
+        </p:txBody>
+      </p:sp>
+      <p:sp>
+        <p:nvSpPr>
+          <p:cNvPr id="5" name="Text 3"/>
+          <p:cNvSpPr/>
+          <p:nvPr/>
+        </p:nvSpPr>
+        <p:spPr>
+          <a:xfrm>
+            <a:off x="822960" y="2441448"/>
+            <a:ext cx="10543032" cy="3959352"/>
           </a:xfrm>
           <a:prstGeom prst="rect">
             <a:avLst/>
@@ -4201,106 +4433,106 @@
           <a:p>
             <a:pPr algn="l" indent="0" marL="0">
               <a:lnSpc>
-                <a:spcPct val="110000"/>
+                <a:spcPct val="115000"/>
               </a:lnSpc>
               <a:spcAft>
-                <a:spcPts val="1800"/>
+                <a:spcPts val="1600"/>
               </a:spcAft>
               <a:buNone/>
             </a:pPr>
             <a:r>
-              <a:rPr lang="en-US" sz="2800" dirty="0">
-                <a:solidFill>
-                  <a:srgbClr val="0070C0"/>
-                </a:solidFill>
-                <a:latin typeface="Calibri" pitchFamily="34" charset="0"/>
-                <a:ea typeface="Calibri" pitchFamily="34" charset="-122"/>
-                <a:cs typeface="Calibri" pitchFamily="34" charset="-120"/>
+              <a:rPr lang="en-US" sz="2000" dirty="0">
+                <a:solidFill>
+                  <a:srgbClr val="2E7A72"/>
+                </a:solidFill>
+                <a:latin typeface="Avenir Next" pitchFamily="34" charset="0"/>
+                <a:ea typeface="Avenir Next" pitchFamily="34" charset="-122"/>
+                <a:cs typeface="Avenir Next" pitchFamily="34" charset="-120"/>
               </a:rPr>
               <a:t>You describe what you want, in plain English.</a:t>
             </a:r>
-            <a:endParaRPr lang="en-US" sz="2800" dirty="0"/>
+            <a:endParaRPr lang="en-US" sz="2000" dirty="0"/>
           </a:p>
           <a:p>
             <a:pPr algn="l" indent="0" marL="0">
               <a:lnSpc>
-                <a:spcPct val="110000"/>
+                <a:spcPct val="115000"/>
               </a:lnSpc>
               <a:spcAft>
-                <a:spcPts val="1800"/>
+                <a:spcPts val="1600"/>
               </a:spcAft>
               <a:buNone/>
             </a:pPr>
             <a:r>
-              <a:rPr lang="en-US" sz="2800" dirty="0">
-                <a:solidFill>
-                  <a:srgbClr val="000000"/>
-                </a:solidFill>
-                <a:latin typeface="Calibri" pitchFamily="34" charset="0"/>
-                <a:ea typeface="Calibri" pitchFamily="34" charset="-122"/>
-                <a:cs typeface="Calibri" pitchFamily="34" charset="-120"/>
+              <a:rPr lang="en-US" sz="2000" dirty="0">
+                <a:solidFill>
+                  <a:srgbClr val="111111"/>
+                </a:solidFill>
+                <a:latin typeface="Avenir Next" pitchFamily="34" charset="0"/>
+                <a:ea typeface="Avenir Next" pitchFamily="34" charset="-122"/>
+                <a:cs typeface="Avenir Next" pitchFamily="34" charset="-120"/>
               </a:rPr>
               <a:t>It builds the thing - a page, a tracker, a tool.</a:t>
             </a:r>
-            <a:endParaRPr lang="en-US" sz="2800" dirty="0"/>
+            <a:endParaRPr lang="en-US" sz="2000" dirty="0"/>
           </a:p>
           <a:p>
             <a:pPr algn="l" indent="0" marL="0">
               <a:lnSpc>
-                <a:spcPct val="110000"/>
+                <a:spcPct val="115000"/>
               </a:lnSpc>
               <a:spcAft>
-                <a:spcPts val="1800"/>
+                <a:spcPts val="1600"/>
               </a:spcAft>
               <a:buNone/>
             </a:pPr>
             <a:r>
-              <a:rPr lang="en-US" sz="2800" dirty="0">
-                <a:solidFill>
-                  <a:srgbClr val="00B050"/>
-                </a:solidFill>
-                <a:latin typeface="Calibri" pitchFamily="34" charset="0"/>
-                <a:ea typeface="Calibri" pitchFamily="34" charset="-122"/>
-                <a:cs typeface="Calibri" pitchFamily="34" charset="-120"/>
+              <a:rPr lang="en-US" sz="2000" dirty="0">
+                <a:solidFill>
+                  <a:srgbClr val="2E7A72"/>
+                </a:solidFill>
+                <a:latin typeface="Avenir Next" pitchFamily="34" charset="0"/>
+                <a:ea typeface="Avenir Next" pitchFamily="34" charset="-122"/>
+                <a:cs typeface="Avenir Next" pitchFamily="34" charset="-120"/>
               </a:rPr>
               <a:t>You want it different? You just say so.</a:t>
             </a:r>
-            <a:endParaRPr lang="en-US" sz="2800" dirty="0"/>
+            <a:endParaRPr lang="en-US" sz="2000" dirty="0"/>
           </a:p>
           <a:p>
             <a:pPr algn="l" indent="0" marL="0">
               <a:lnSpc>
-                <a:spcPct val="110000"/>
+                <a:spcPct val="115000"/>
               </a:lnSpc>
               <a:spcAft>
-                <a:spcPts val="1800"/>
+                <a:spcPts val="1600"/>
               </a:spcAft>
               <a:buNone/>
             </a:pPr>
-            <a:endParaRPr lang="en-US" sz="2800" dirty="0"/>
+            <a:endParaRPr lang="en-US" sz="2000" dirty="0"/>
           </a:p>
           <a:p>
             <a:pPr algn="l" indent="0" marL="0">
               <a:lnSpc>
-                <a:spcPct val="110000"/>
+                <a:spcPct val="115000"/>
               </a:lnSpc>
               <a:spcAft>
-                <a:spcPts val="1800"/>
+                <a:spcPts val="1600"/>
               </a:spcAft>
               <a:buNone/>
             </a:pPr>
             <a:r>
-              <a:rPr lang="en-US" sz="2800" dirty="0">
-                <a:solidFill>
-                  <a:srgbClr val="800000"/>
-                </a:solidFill>
-                <a:latin typeface="Calibri" pitchFamily="34" charset="0"/>
-                <a:ea typeface="Calibri" pitchFamily="34" charset="-122"/>
-                <a:cs typeface="Calibri" pitchFamily="34" charset="-120"/>
+              <a:rPr lang="en-US" sz="2000" b="1" dirty="0">
+                <a:solidFill>
+                  <a:srgbClr val="111111"/>
+                </a:solidFill>
+                <a:latin typeface="Avenir Next" pitchFamily="34" charset="0"/>
+                <a:ea typeface="Avenir Next" pitchFamily="34" charset="-122"/>
+                <a:cs typeface="Avenir Next" pitchFamily="34" charset="-120"/>
               </a:rPr>
               <a:t>You never have to look at the code.</a:t>
             </a:r>
-            <a:endParaRPr lang="en-US" sz="2800" dirty="0"/>
+            <a:endParaRPr lang="en-US" sz="2000" dirty="0"/>
           </a:p>
         </p:txBody>
       </p:sp>
@@ -4329,40 +4561,16 @@
           <a:chExt cx="0" cy="0"/>
         </a:xfrm>
       </p:grpSpPr>
-      <p:pic>
-        <p:nvPicPr>
-          <p:cNvPr id="2" name="Image 0" descr="/Users/batuhangundogdu/Claude Code Workshop/deck/assets/uchicago-footer.png">    </p:cNvPr>
-          <p:cNvPicPr>
-            <a:picLocks noChangeAspect="1"/>
-          </p:cNvPicPr>
-          <p:nvPr/>
-        </p:nvPicPr>
-        <p:blipFill>
-          <a:blip r:embed="rId1"/>
-          <a:stretch>
-            <a:fillRect/>
-          </a:stretch>
-        </p:blipFill>
-        <p:spPr>
-          <a:xfrm>
-            <a:off x="539496" y="6382512"/>
-            <a:ext cx="2843784" cy="475488"/>
-          </a:xfrm>
-          <a:prstGeom prst="rect">
-            <a:avLst/>
-          </a:prstGeom>
-        </p:spPr>
-      </p:pic>
-      <p:sp>
-        <p:nvSpPr>
-          <p:cNvPr id="3" name="Text 0"/>
-          <p:cNvSpPr/>
-          <p:nvPr/>
-        </p:nvSpPr>
-        <p:spPr>
-          <a:xfrm>
-            <a:off x="548640" y="365760"/>
-            <a:ext cx="11091672" cy="1188720"/>
+      <p:sp>
+        <p:nvSpPr>
+          <p:cNvPr id="2" name="Text 0"/>
+          <p:cNvSpPr/>
+          <p:nvPr/>
+        </p:nvSpPr>
+        <p:spPr>
+          <a:xfrm>
+            <a:off x="822960" y="658368"/>
+            <a:ext cx="10543032" cy="274320"/>
           </a:xfrm>
           <a:prstGeom prst="rect">
             <a:avLst/>
@@ -4378,30 +4586,92 @@
               <a:buNone/>
             </a:pPr>
             <a:r>
-              <a:rPr lang="en-US" sz="5000" b="1" dirty="0">
-                <a:solidFill>
-                  <a:srgbClr val="000000"/>
-                </a:solidFill>
-                <a:latin typeface="Calibri" pitchFamily="34" charset="0"/>
-                <a:ea typeface="Calibri" pitchFamily="34" charset="-122"/>
-                <a:cs typeface="Calibri" pitchFamily="34" charset="-120"/>
+              <a:rPr lang="en-US" sz="1200" b="1" spc="250" kern="0" dirty="0">
+                <a:solidFill>
+                  <a:srgbClr val="9A9A9A"/>
+                </a:solidFill>
+                <a:latin typeface="Avenir Next" pitchFamily="34" charset="0"/>
+                <a:ea typeface="Avenir Next" pitchFamily="34" charset="-122"/>
+                <a:cs typeface="Avenir Next" pitchFamily="34" charset="-120"/>
+              </a:rPr>
+              <a:t>MYTHS VS REALITY</a:t>
+            </a:r>
+            <a:endParaRPr lang="en-US" sz="1200" dirty="0"/>
+          </a:p>
+        </p:txBody>
+      </p:sp>
+      <p:sp>
+        <p:nvSpPr>
+          <p:cNvPr id="3" name="Shape 1"/>
+          <p:cNvSpPr/>
+          <p:nvPr/>
+        </p:nvSpPr>
+        <p:spPr>
+          <a:xfrm>
+            <a:off x="822960" y="969264"/>
+            <a:ext cx="566928" cy="41148"/>
+          </a:xfrm>
+          <a:prstGeom prst="rect">
+            <a:avLst/>
+          </a:prstGeom>
+          <a:solidFill>
+            <a:srgbClr val="2E7A72"/>
+          </a:solidFill>
+          <a:ln/>
+        </p:spPr>
+      </p:sp>
+      <p:sp>
+        <p:nvSpPr>
+          <p:cNvPr id="4" name="Text 2"/>
+          <p:cNvSpPr/>
+          <p:nvPr/>
+        </p:nvSpPr>
+        <p:spPr>
+          <a:xfrm>
+            <a:off x="822960" y="1161288"/>
+            <a:ext cx="10543032" cy="1188720"/>
+          </a:xfrm>
+          <a:prstGeom prst="rect">
+            <a:avLst/>
+          </a:prstGeom>
+          <a:noFill/>
+          <a:ln/>
+        </p:spPr>
+        <p:txBody>
+          <a:bodyPr wrap="square" lIns="0" tIns="0" rIns="0" bIns="0" rtlCol="0" anchor="t"/>
+          <a:lstStyle/>
+          <a:p>
+            <a:pPr algn="l" indent="0" marL="0">
+              <a:lnSpc>
+                <a:spcPct val="98000"/>
+              </a:lnSpc>
+              <a:buNone/>
+            </a:pPr>
+            <a:r>
+              <a:rPr lang="en-US" sz="4000" b="1" dirty="0">
+                <a:solidFill>
+                  <a:srgbClr val="111111"/>
+                </a:solidFill>
+                <a:latin typeface="Avenir Next" pitchFamily="34" charset="0"/>
+                <a:ea typeface="Avenir Next" pitchFamily="34" charset="-122"/>
+                <a:cs typeface="Avenir Next" pitchFamily="34" charset="-120"/>
               </a:rPr>
               <a:t>What people assume vs. what's true</a:t>
             </a:r>
-            <a:endParaRPr lang="en-US" sz="5000" dirty="0"/>
-          </a:p>
-        </p:txBody>
-      </p:sp>
-      <p:sp>
-        <p:nvSpPr>
-          <p:cNvPr id="4" name="Text 1"/>
-          <p:cNvSpPr/>
-          <p:nvPr/>
-        </p:nvSpPr>
-        <p:spPr>
-          <a:xfrm>
-            <a:off x="548640" y="1920240"/>
-            <a:ext cx="5271516" cy="4297680"/>
+            <a:endParaRPr lang="en-US" sz="4000" dirty="0"/>
+          </a:p>
+        </p:txBody>
+      </p:sp>
+      <p:sp>
+        <p:nvSpPr>
+          <p:cNvPr id="5" name="Text 3"/>
+          <p:cNvSpPr/>
+          <p:nvPr/>
+        </p:nvSpPr>
+        <p:spPr>
+          <a:xfrm>
+            <a:off x="822960" y="2441448"/>
+            <a:ext cx="4905756" cy="3959352"/>
           </a:xfrm>
           <a:prstGeom prst="rect">
             <a:avLst/>
@@ -4415,107 +4685,107 @@
           <a:p>
             <a:pPr algn="l" indent="0" marL="0">
               <a:lnSpc>
-                <a:spcPct val="110000"/>
+                <a:spcPct val="115000"/>
               </a:lnSpc>
               <a:spcAft>
-                <a:spcPts val="1600"/>
+                <a:spcPts val="1400"/>
               </a:spcAft>
               <a:buNone/>
             </a:pPr>
             <a:r>
-              <a:rPr lang="en-US" sz="2800" dirty="0">
-                <a:solidFill>
-                  <a:srgbClr val="800000"/>
-                </a:solidFill>
-                <a:latin typeface="Calibri" pitchFamily="34" charset="0"/>
-                <a:ea typeface="Calibri" pitchFamily="34" charset="-122"/>
-                <a:cs typeface="Calibri" pitchFamily="34" charset="-120"/>
+              <a:rPr lang="en-US" sz="2000" b="1" dirty="0">
+                <a:solidFill>
+                  <a:srgbClr val="111111"/>
+                </a:solidFill>
+                <a:latin typeface="Avenir Next" pitchFamily="34" charset="0"/>
+                <a:ea typeface="Avenir Next" pitchFamily="34" charset="-122"/>
+                <a:cs typeface="Avenir Next" pitchFamily="34" charset="-120"/>
               </a:rPr>
               <a:t>The assumption</a:t>
             </a:r>
-            <a:endParaRPr lang="en-US" sz="2800" dirty="0"/>
+            <a:endParaRPr lang="en-US" sz="2000" dirty="0"/>
           </a:p>
           <a:p>
             <a:pPr algn="l" indent="0" marL="0">
               <a:lnSpc>
-                <a:spcPct val="110000"/>
+                <a:spcPct val="115000"/>
               </a:lnSpc>
               <a:spcAft>
-                <a:spcPts val="1600"/>
+                <a:spcPts val="1400"/>
               </a:spcAft>
               <a:buNone/>
             </a:pPr>
             <a:r>
-              <a:rPr lang="en-US" sz="2800" dirty="0">
-                <a:solidFill>
-                  <a:srgbClr val="000000"/>
-                </a:solidFill>
-                <a:latin typeface="Calibri" pitchFamily="34" charset="0"/>
-                <a:ea typeface="Calibri" pitchFamily="34" charset="-122"/>
-                <a:cs typeface="Calibri" pitchFamily="34" charset="-120"/>
+              <a:rPr lang="en-US" sz="2000" dirty="0">
+                <a:solidFill>
+                  <a:srgbClr val="111111"/>
+                </a:solidFill>
+                <a:latin typeface="Avenir Next" pitchFamily="34" charset="0"/>
+                <a:ea typeface="Avenir Next" pitchFamily="34" charset="-122"/>
+                <a:cs typeface="Avenir Next" pitchFamily="34" charset="-120"/>
               </a:rPr>
               <a:t>“It's for programmers.”</a:t>
             </a:r>
-            <a:endParaRPr lang="en-US" sz="2800" dirty="0"/>
+            <a:endParaRPr lang="en-US" sz="2000" dirty="0"/>
           </a:p>
           <a:p>
             <a:pPr algn="l" indent="0" marL="0">
               <a:lnSpc>
-                <a:spcPct val="110000"/>
+                <a:spcPct val="115000"/>
               </a:lnSpc>
               <a:spcAft>
-                <a:spcPts val="1600"/>
+                <a:spcPts val="1400"/>
               </a:spcAft>
               <a:buNone/>
             </a:pPr>
             <a:r>
-              <a:rPr lang="en-US" sz="2800" dirty="0">
-                <a:solidFill>
-                  <a:srgbClr val="000000"/>
-                </a:solidFill>
-                <a:latin typeface="Calibri" pitchFamily="34" charset="0"/>
-                <a:ea typeface="Calibri" pitchFamily="34" charset="-122"/>
-                <a:cs typeface="Calibri" pitchFamily="34" charset="-120"/>
+              <a:rPr lang="en-US" sz="2000" dirty="0">
+                <a:solidFill>
+                  <a:srgbClr val="111111"/>
+                </a:solidFill>
+                <a:latin typeface="Avenir Next" pitchFamily="34" charset="0"/>
+                <a:ea typeface="Avenir Next" pitchFamily="34" charset="-122"/>
+                <a:cs typeface="Avenir Next" pitchFamily="34" charset="-120"/>
               </a:rPr>
               <a:t>“I'll have to learn to code.”</a:t>
             </a:r>
-            <a:endParaRPr lang="en-US" sz="2800" dirty="0"/>
+            <a:endParaRPr lang="en-US" sz="2000" dirty="0"/>
           </a:p>
           <a:p>
             <a:pPr algn="l" indent="0" marL="0">
               <a:lnSpc>
-                <a:spcPct val="110000"/>
+                <a:spcPct val="115000"/>
               </a:lnSpc>
               <a:spcAft>
-                <a:spcPts val="1600"/>
+                <a:spcPts val="1400"/>
               </a:spcAft>
               <a:buNone/>
             </a:pPr>
             <a:r>
-              <a:rPr lang="en-US" sz="2800" dirty="0">
-                <a:solidFill>
-                  <a:srgbClr val="000000"/>
-                </a:solidFill>
-                <a:latin typeface="Calibri" pitchFamily="34" charset="0"/>
-                <a:ea typeface="Calibri" pitchFamily="34" charset="-122"/>
-                <a:cs typeface="Calibri" pitchFamily="34" charset="-120"/>
+              <a:rPr lang="en-US" sz="2000" dirty="0">
+                <a:solidFill>
+                  <a:srgbClr val="111111"/>
+                </a:solidFill>
+                <a:latin typeface="Avenir Next" pitchFamily="34" charset="0"/>
+                <a:ea typeface="Avenir Next" pitchFamily="34" charset="-122"/>
+                <a:cs typeface="Avenir Next" pitchFamily="34" charset="-120"/>
               </a:rPr>
               <a:t>“It'll break and I won't know why.”</a:t>
             </a:r>
-            <a:endParaRPr lang="en-US" sz="2800" dirty="0"/>
-          </a:p>
-        </p:txBody>
-      </p:sp>
-      <p:sp>
-        <p:nvSpPr>
-          <p:cNvPr id="5" name="Text 2"/>
-          <p:cNvSpPr/>
-          <p:nvPr/>
-        </p:nvSpPr>
-        <p:spPr>
-          <a:xfrm>
-            <a:off x="6368796" y="1920240"/>
-            <a:ext cx="5271516" cy="4297680"/>
+            <a:endParaRPr lang="en-US" sz="2000" dirty="0"/>
+          </a:p>
+        </p:txBody>
+      </p:sp>
+      <p:sp>
+        <p:nvSpPr>
+          <p:cNvPr id="6" name="Text 4"/>
+          <p:cNvSpPr/>
+          <p:nvPr/>
+        </p:nvSpPr>
+        <p:spPr>
+          <a:xfrm>
+            <a:off x="6460236" y="2441448"/>
+            <a:ext cx="4905756" cy="3959352"/>
           </a:xfrm>
           <a:prstGeom prst="rect">
             <a:avLst/>
@@ -4529,94 +4799,94 @@
           <a:p>
             <a:pPr algn="l" indent="0" marL="0">
               <a:lnSpc>
-                <a:spcPct val="110000"/>
+                <a:spcPct val="115000"/>
               </a:lnSpc>
               <a:spcAft>
-                <a:spcPts val="1600"/>
+                <a:spcPts val="1400"/>
               </a:spcAft>
               <a:buNone/>
             </a:pPr>
             <a:r>
-              <a:rPr lang="en-US" sz="2800" dirty="0">
-                <a:solidFill>
-                  <a:srgbClr val="800000"/>
-                </a:solidFill>
-                <a:latin typeface="Calibri" pitchFamily="34" charset="0"/>
-                <a:ea typeface="Calibri" pitchFamily="34" charset="-122"/>
-                <a:cs typeface="Calibri" pitchFamily="34" charset="-120"/>
+              <a:rPr lang="en-US" sz="2000" b="1" dirty="0">
+                <a:solidFill>
+                  <a:srgbClr val="111111"/>
+                </a:solidFill>
+                <a:latin typeface="Avenir Next" pitchFamily="34" charset="0"/>
+                <a:ea typeface="Avenir Next" pitchFamily="34" charset="-122"/>
+                <a:cs typeface="Avenir Next" pitchFamily="34" charset="-120"/>
               </a:rPr>
               <a:t>The reality</a:t>
             </a:r>
-            <a:endParaRPr lang="en-US" sz="2800" dirty="0"/>
+            <a:endParaRPr lang="en-US" sz="2000" dirty="0"/>
           </a:p>
           <a:p>
             <a:pPr algn="l" indent="0" marL="0">
               <a:lnSpc>
-                <a:spcPct val="110000"/>
+                <a:spcPct val="115000"/>
               </a:lnSpc>
               <a:spcAft>
-                <a:spcPts val="1600"/>
+                <a:spcPts val="1400"/>
               </a:spcAft>
               <a:buNone/>
             </a:pPr>
             <a:r>
-              <a:rPr lang="en-US" sz="2800" dirty="0">
-                <a:solidFill>
-                  <a:srgbClr val="00B050"/>
-                </a:solidFill>
-                <a:latin typeface="Calibri" pitchFamily="34" charset="0"/>
-                <a:ea typeface="Calibri" pitchFamily="34" charset="-122"/>
-                <a:cs typeface="Calibri" pitchFamily="34" charset="-120"/>
+              <a:rPr lang="en-US" sz="2000" dirty="0">
+                <a:solidFill>
+                  <a:srgbClr val="2E7A72"/>
+                </a:solidFill>
+                <a:latin typeface="Avenir Next" pitchFamily="34" charset="0"/>
+                <a:ea typeface="Avenir Next" pitchFamily="34" charset="-122"/>
+                <a:cs typeface="Avenir Next" pitchFamily="34" charset="-120"/>
               </a:rPr>
               <a:t>It's for anyone with a task.</a:t>
             </a:r>
-            <a:endParaRPr lang="en-US" sz="2800" dirty="0"/>
+            <a:endParaRPr lang="en-US" sz="2000" dirty="0"/>
           </a:p>
           <a:p>
             <a:pPr algn="l" indent="0" marL="0">
               <a:lnSpc>
-                <a:spcPct val="110000"/>
+                <a:spcPct val="115000"/>
               </a:lnSpc>
               <a:spcAft>
-                <a:spcPts val="1600"/>
+                <a:spcPts val="1400"/>
               </a:spcAft>
               <a:buNone/>
             </a:pPr>
             <a:r>
-              <a:rPr lang="en-US" sz="2800" dirty="0">
-                <a:solidFill>
-                  <a:srgbClr val="00B050"/>
-                </a:solidFill>
-                <a:latin typeface="Calibri" pitchFamily="34" charset="0"/>
-                <a:ea typeface="Calibri" pitchFamily="34" charset="-122"/>
-                <a:cs typeface="Calibri" pitchFamily="34" charset="-120"/>
+              <a:rPr lang="en-US" sz="2000" dirty="0">
+                <a:solidFill>
+                  <a:srgbClr val="2E7A72"/>
+                </a:solidFill>
+                <a:latin typeface="Avenir Next" pitchFamily="34" charset="0"/>
+                <a:ea typeface="Avenir Next" pitchFamily="34" charset="-122"/>
+                <a:cs typeface="Avenir Next" pitchFamily="34" charset="-120"/>
               </a:rPr>
               <a:t>You describe; it writes.</a:t>
             </a:r>
-            <a:endParaRPr lang="en-US" sz="2800" dirty="0"/>
+            <a:endParaRPr lang="en-US" sz="2000" dirty="0"/>
           </a:p>
           <a:p>
             <a:pPr algn="l" indent="0" marL="0">
               <a:lnSpc>
-                <a:spcPct val="110000"/>
+                <a:spcPct val="115000"/>
               </a:lnSpc>
               <a:spcAft>
-                <a:spcPts val="1600"/>
+                <a:spcPts val="1400"/>
               </a:spcAft>
               <a:buNone/>
             </a:pPr>
             <a:r>
-              <a:rPr lang="en-US" sz="2800" dirty="0">
-                <a:solidFill>
-                  <a:srgbClr val="00B050"/>
-                </a:solidFill>
-                <a:latin typeface="Calibri" pitchFamily="34" charset="0"/>
-                <a:ea typeface="Calibri" pitchFamily="34" charset="-122"/>
-                <a:cs typeface="Calibri" pitchFamily="34" charset="-120"/>
+              <a:rPr lang="en-US" sz="2000" dirty="0">
+                <a:solidFill>
+                  <a:srgbClr val="2E7A72"/>
+                </a:solidFill>
+                <a:latin typeface="Avenir Next" pitchFamily="34" charset="0"/>
+                <a:ea typeface="Avenir Next" pitchFamily="34" charset="-122"/>
+                <a:cs typeface="Avenir Next" pitchFamily="34" charset="-120"/>
               </a:rPr>
               <a:t>You say “that's wrong, fix it.”</a:t>
             </a:r>
-            <a:endParaRPr lang="en-US" sz="2800" dirty="0"/>
+            <a:endParaRPr lang="en-US" sz="2000" dirty="0"/>
           </a:p>
         </p:txBody>
       </p:sp>
@@ -4645,40 +4915,16 @@
           <a:chExt cx="0" cy="0"/>
         </a:xfrm>
       </p:grpSpPr>
-      <p:pic>
-        <p:nvPicPr>
-          <p:cNvPr id="2" name="Image 0" descr="/Users/batuhangundogdu/Claude Code Workshop/deck/assets/uchicago-footer.png">    </p:cNvPr>
-          <p:cNvPicPr>
-            <a:picLocks noChangeAspect="1"/>
-          </p:cNvPicPr>
-          <p:nvPr/>
-        </p:nvPicPr>
-        <p:blipFill>
-          <a:blip r:embed="rId1"/>
-          <a:stretch>
-            <a:fillRect/>
-          </a:stretch>
-        </p:blipFill>
-        <p:spPr>
-          <a:xfrm>
-            <a:off x="539496" y="6382512"/>
-            <a:ext cx="2843784" cy="475488"/>
-          </a:xfrm>
-          <a:prstGeom prst="rect">
-            <a:avLst/>
-          </a:prstGeom>
-        </p:spPr>
-      </p:pic>
-      <p:sp>
-        <p:nvSpPr>
-          <p:cNvPr id="3" name="Text 0"/>
-          <p:cNvSpPr/>
-          <p:nvPr/>
-        </p:nvSpPr>
-        <p:spPr>
-          <a:xfrm>
-            <a:off x="548640" y="365760"/>
-            <a:ext cx="11091672" cy="1188720"/>
+      <p:sp>
+        <p:nvSpPr>
+          <p:cNvPr id="2" name="Text 0"/>
+          <p:cNvSpPr/>
+          <p:nvPr/>
+        </p:nvSpPr>
+        <p:spPr>
+          <a:xfrm>
+            <a:off x="822960" y="658368"/>
+            <a:ext cx="10543032" cy="274320"/>
           </a:xfrm>
           <a:prstGeom prst="rect">
             <a:avLst/>
@@ -4694,30 +4940,92 @@
               <a:buNone/>
             </a:pPr>
             <a:r>
-              <a:rPr lang="en-US" sz="5000" b="1" dirty="0">
-                <a:solidFill>
-                  <a:srgbClr val="000000"/>
-                </a:solidFill>
-                <a:latin typeface="Calibri" pitchFamily="34" charset="0"/>
-                <a:ea typeface="Calibri" pitchFamily="34" charset="-122"/>
-                <a:cs typeface="Calibri" pitchFamily="34" charset="-120"/>
+              <a:rPr lang="en-US" sz="1200" b="1" spc="250" kern="0" dirty="0">
+                <a:solidFill>
+                  <a:srgbClr val="9A9A9A"/>
+                </a:solidFill>
+                <a:latin typeface="Avenir Next" pitchFamily="34" charset="0"/>
+                <a:ea typeface="Avenir Next" pitchFamily="34" charset="-122"/>
+                <a:cs typeface="Avenir Next" pitchFamily="34" charset="-120"/>
+              </a:rPr>
+              <a:t>BEFORE WE START</a:t>
+            </a:r>
+            <a:endParaRPr lang="en-US" sz="1200" dirty="0"/>
+          </a:p>
+        </p:txBody>
+      </p:sp>
+      <p:sp>
+        <p:nvSpPr>
+          <p:cNvPr id="3" name="Shape 1"/>
+          <p:cNvSpPr/>
+          <p:nvPr/>
+        </p:nvSpPr>
+        <p:spPr>
+          <a:xfrm>
+            <a:off x="822960" y="969264"/>
+            <a:ext cx="566928" cy="41148"/>
+          </a:xfrm>
+          <a:prstGeom prst="rect">
+            <a:avLst/>
+          </a:prstGeom>
+          <a:solidFill>
+            <a:srgbClr val="2E7A72"/>
+          </a:solidFill>
+          <a:ln/>
+        </p:spPr>
+      </p:sp>
+      <p:sp>
+        <p:nvSpPr>
+          <p:cNvPr id="4" name="Text 2"/>
+          <p:cNvSpPr/>
+          <p:nvPr/>
+        </p:nvSpPr>
+        <p:spPr>
+          <a:xfrm>
+            <a:off x="822960" y="1161288"/>
+            <a:ext cx="10543032" cy="1188720"/>
+          </a:xfrm>
+          <a:prstGeom prst="rect">
+            <a:avLst/>
+          </a:prstGeom>
+          <a:noFill/>
+          <a:ln/>
+        </p:spPr>
+        <p:txBody>
+          <a:bodyPr wrap="square" lIns="0" tIns="0" rIns="0" bIns="0" rtlCol="0" anchor="t"/>
+          <a:lstStyle/>
+          <a:p>
+            <a:pPr algn="l" indent="0" marL="0">
+              <a:lnSpc>
+                <a:spcPct val="98000"/>
+              </a:lnSpc>
+              <a:buNone/>
+            </a:pPr>
+            <a:r>
+              <a:rPr lang="en-US" sz="4000" b="1" dirty="0">
+                <a:solidFill>
+                  <a:srgbClr val="111111"/>
+                </a:solidFill>
+                <a:latin typeface="Avenir Next" pitchFamily="34" charset="0"/>
+                <a:ea typeface="Avenir Next" pitchFamily="34" charset="-122"/>
+                <a:cs typeface="Avenir Next" pitchFamily="34" charset="-120"/>
               </a:rPr>
               <a:t>One small thing before we start…</a:t>
             </a:r>
-            <a:endParaRPr lang="en-US" sz="5000" dirty="0"/>
-          </a:p>
-        </p:txBody>
-      </p:sp>
-      <p:sp>
-        <p:nvSpPr>
-          <p:cNvPr id="4" name="Text 1"/>
-          <p:cNvSpPr/>
-          <p:nvPr/>
-        </p:nvSpPr>
-        <p:spPr>
-          <a:xfrm>
-            <a:off x="548640" y="1920240"/>
-            <a:ext cx="11091672" cy="4297680"/>
+            <a:endParaRPr lang="en-US" sz="4000" dirty="0"/>
+          </a:p>
+        </p:txBody>
+      </p:sp>
+      <p:sp>
+        <p:nvSpPr>
+          <p:cNvPr id="5" name="Text 3"/>
+          <p:cNvSpPr/>
+          <p:nvPr/>
+        </p:nvSpPr>
+        <p:spPr>
+          <a:xfrm>
+            <a:off x="822960" y="2441448"/>
+            <a:ext cx="10543032" cy="3959352"/>
           </a:xfrm>
           <a:prstGeom prst="rect">
             <a:avLst/>
@@ -4731,83 +5039,83 @@
           <a:p>
             <a:pPr algn="l" indent="0" marL="0">
               <a:lnSpc>
-                <a:spcPct val="110000"/>
+                <a:spcPct val="115000"/>
               </a:lnSpc>
               <a:spcAft>
-                <a:spcPts val="1800"/>
+                <a:spcPts val="1600"/>
               </a:spcAft>
               <a:buNone/>
             </a:pPr>
             <a:r>
-              <a:rPr lang="en-US" sz="2800" dirty="0">
-                <a:solidFill>
-                  <a:srgbClr val="0070C0"/>
-                </a:solidFill>
-                <a:latin typeface="Calibri" pitchFamily="34" charset="0"/>
-                <a:ea typeface="Calibri" pitchFamily="34" charset="-122"/>
-                <a:cs typeface="Calibri" pitchFamily="34" charset="-120"/>
+              <a:rPr lang="en-US" sz="2000" dirty="0">
+                <a:solidFill>
+                  <a:srgbClr val="2E7A72"/>
+                </a:solidFill>
+                <a:latin typeface="Avenir Next" pitchFamily="34" charset="0"/>
+                <a:ea typeface="Avenir Next" pitchFamily="34" charset="-122"/>
+                <a:cs typeface="Avenir Next" pitchFamily="34" charset="-120"/>
               </a:rPr>
               <a:t>These slides were made by talking to Claude Code.</a:t>
             </a:r>
-            <a:endParaRPr lang="en-US" sz="2800" dirty="0"/>
+            <a:endParaRPr lang="en-US" sz="2000" dirty="0"/>
           </a:p>
           <a:p>
             <a:pPr algn="l" indent="0" marL="0">
               <a:lnSpc>
-                <a:spcPct val="110000"/>
+                <a:spcPct val="115000"/>
               </a:lnSpc>
               <a:spcAft>
-                <a:spcPts val="1800"/>
+                <a:spcPts val="1600"/>
               </a:spcAft>
               <a:buNone/>
             </a:pPr>
             <a:r>
-              <a:rPr lang="en-US" sz="2800" dirty="0">
-                <a:solidFill>
-                  <a:srgbClr val="0070C0"/>
-                </a:solidFill>
-                <a:latin typeface="Calibri" pitchFamily="34" charset="0"/>
-                <a:ea typeface="Calibri" pitchFamily="34" charset="-122"/>
-                <a:cs typeface="Calibri" pitchFamily="34" charset="-120"/>
+              <a:rPr lang="en-US" sz="2000" dirty="0">
+                <a:solidFill>
+                  <a:srgbClr val="2E7A72"/>
+                </a:solidFill>
+                <a:latin typeface="Avenir Next" pitchFamily="34" charset="0"/>
+                <a:ea typeface="Avenir Next" pitchFamily="34" charset="-122"/>
+                <a:cs typeface="Avenir Next" pitchFamily="34" charset="-120"/>
               </a:rPr>
               <a:t>So were the four apps you're about to see.</a:t>
             </a:r>
-            <a:endParaRPr lang="en-US" sz="2800" dirty="0"/>
+            <a:endParaRPr lang="en-US" sz="2000" dirty="0"/>
           </a:p>
           <a:p>
             <a:pPr algn="l" indent="0" marL="0">
               <a:lnSpc>
-                <a:spcPct val="110000"/>
+                <a:spcPct val="115000"/>
               </a:lnSpc>
               <a:spcAft>
-                <a:spcPts val="1800"/>
+                <a:spcPts val="1600"/>
               </a:spcAft>
               <a:buNone/>
             </a:pPr>
-            <a:endParaRPr lang="en-US" sz="2800" dirty="0"/>
+            <a:endParaRPr lang="en-US" sz="2000" dirty="0"/>
           </a:p>
           <a:p>
             <a:pPr algn="l" indent="0" marL="0">
               <a:lnSpc>
-                <a:spcPct val="110000"/>
+                <a:spcPct val="115000"/>
               </a:lnSpc>
               <a:spcAft>
-                <a:spcPts val="1800"/>
+                <a:spcPts val="1600"/>
               </a:spcAft>
               <a:buNone/>
             </a:pPr>
             <a:r>
-              <a:rPr lang="en-US" sz="2800" dirty="0">
-                <a:solidFill>
-                  <a:srgbClr val="800000"/>
-                </a:solidFill>
-                <a:latin typeface="Calibri" pitchFamily="34" charset="0"/>
-                <a:ea typeface="Calibri" pitchFamily="34" charset="-122"/>
-                <a:cs typeface="Calibri" pitchFamily="34" charset="-120"/>
+              <a:rPr lang="en-US" sz="2000" b="1" dirty="0">
+                <a:solidFill>
+                  <a:srgbClr val="111111"/>
+                </a:solidFill>
+                <a:latin typeface="Avenir Next" pitchFamily="34" charset="0"/>
+                <a:ea typeface="Avenir Next" pitchFamily="34" charset="-122"/>
+                <a:cs typeface="Avenir Next" pitchFamily="34" charset="-120"/>
               </a:rPr>
               <a:t>Hold that thought. We'll come back to it.</a:t>
             </a:r>
-            <a:endParaRPr lang="en-US" sz="2800" dirty="0"/>
+            <a:endParaRPr lang="en-US" sz="2000" dirty="0"/>
           </a:p>
         </p:txBody>
       </p:sp>
@@ -4836,40 +5144,16 @@
           <a:chExt cx="0" cy="0"/>
         </a:xfrm>
       </p:grpSpPr>
-      <p:pic>
-        <p:nvPicPr>
-          <p:cNvPr id="2" name="Image 0" descr="/Users/batuhangundogdu/Claude Code Workshop/deck/assets/uchicago-footer.png">    </p:cNvPr>
-          <p:cNvPicPr>
-            <a:picLocks noChangeAspect="1"/>
-          </p:cNvPicPr>
-          <p:nvPr/>
-        </p:nvPicPr>
-        <p:blipFill>
-          <a:blip r:embed="rId1"/>
-          <a:stretch>
-            <a:fillRect/>
-          </a:stretch>
-        </p:blipFill>
-        <p:spPr>
-          <a:xfrm>
-            <a:off x="539496" y="6382512"/>
-            <a:ext cx="2843784" cy="475488"/>
-          </a:xfrm>
-          <a:prstGeom prst="rect">
-            <a:avLst/>
-          </a:prstGeom>
-        </p:spPr>
-      </p:pic>
-      <p:sp>
-        <p:nvSpPr>
-          <p:cNvPr id="3" name="Text 0"/>
-          <p:cNvSpPr/>
-          <p:nvPr/>
-        </p:nvSpPr>
-        <p:spPr>
-          <a:xfrm>
-            <a:off x="548640" y="2468880"/>
-            <a:ext cx="11091672" cy="457200"/>
+      <p:sp>
+        <p:nvSpPr>
+          <p:cNvPr id="2" name="Text 0"/>
+          <p:cNvSpPr/>
+          <p:nvPr/>
+        </p:nvSpPr>
+        <p:spPr>
+          <a:xfrm>
+            <a:off x="822960" y="2514600"/>
+            <a:ext cx="10543032" cy="365760"/>
           </a:xfrm>
           <a:prstGeom prst="rect">
             <a:avLst/>
@@ -4885,30 +5169,50 @@
               <a:buNone/>
             </a:pPr>
             <a:r>
-              <a:rPr lang="en-US" sz="2400" spc="200" kern="0" dirty="0">
-                <a:solidFill>
-                  <a:srgbClr val="800000"/>
-                </a:solidFill>
-                <a:latin typeface="Calibri" pitchFamily="34" charset="0"/>
-                <a:ea typeface="Calibri" pitchFamily="34" charset="-122"/>
-                <a:cs typeface="Calibri" pitchFamily="34" charset="-120"/>
+              <a:rPr lang="en-US" sz="1500" b="1" spc="300" kern="0" dirty="0">
+                <a:solidFill>
+                  <a:srgbClr val="2E7A72"/>
+                </a:solidFill>
+                <a:latin typeface="Avenir Next" pitchFamily="34" charset="0"/>
+                <a:ea typeface="Avenir Next" pitchFamily="34" charset="-122"/>
+                <a:cs typeface="Avenir Next" pitchFamily="34" charset="-120"/>
               </a:rPr>
               <a:t>PART TWO</a:t>
             </a:r>
-            <a:endParaRPr lang="en-US" sz="2400" dirty="0"/>
-          </a:p>
-        </p:txBody>
-      </p:sp>
-      <p:sp>
-        <p:nvSpPr>
-          <p:cNvPr id="4" name="Text 1"/>
-          <p:cNvSpPr/>
-          <p:nvPr/>
-        </p:nvSpPr>
-        <p:spPr>
-          <a:xfrm>
-            <a:off x="548640" y="2926080"/>
-            <a:ext cx="11091672" cy="1463040"/>
+            <a:endParaRPr lang="en-US" sz="1500" dirty="0"/>
+          </a:p>
+        </p:txBody>
+      </p:sp>
+      <p:sp>
+        <p:nvSpPr>
+          <p:cNvPr id="3" name="Shape 1"/>
+          <p:cNvSpPr/>
+          <p:nvPr/>
+        </p:nvSpPr>
+        <p:spPr>
+          <a:xfrm>
+            <a:off x="822960" y="2926080"/>
+            <a:ext cx="566928" cy="41148"/>
+          </a:xfrm>
+          <a:prstGeom prst="rect">
+            <a:avLst/>
+          </a:prstGeom>
+          <a:solidFill>
+            <a:srgbClr val="2E7A72"/>
+          </a:solidFill>
+          <a:ln/>
+        </p:spPr>
+      </p:sp>
+      <p:sp>
+        <p:nvSpPr>
+          <p:cNvPr id="4" name="Text 2"/>
+          <p:cNvSpPr/>
+          <p:nvPr/>
+        </p:nvSpPr>
+        <p:spPr>
+          <a:xfrm>
+            <a:off x="822960" y="3108960"/>
+            <a:ext cx="10543032" cy="1463040"/>
           </a:xfrm>
           <a:prstGeom prst="rect">
             <a:avLst/>
@@ -4921,20 +5225,23 @@
           <a:lstStyle/>
           <a:p>
             <a:pPr algn="l" indent="0" marL="0">
-              <a:buNone/>
-            </a:pPr>
-            <a:r>
-              <a:rPr lang="en-US" sz="5000" b="1" dirty="0">
-                <a:solidFill>
-                  <a:srgbClr val="000000"/>
-                </a:solidFill>
-                <a:latin typeface="Calibri" pitchFamily="34" charset="0"/>
-                <a:ea typeface="Calibri" pitchFamily="34" charset="-122"/>
-                <a:cs typeface="Calibri" pitchFamily="34" charset="-120"/>
+              <a:lnSpc>
+                <a:spcPct val="98000"/>
+              </a:lnSpc>
+              <a:buNone/>
+            </a:pPr>
+            <a:r>
+              <a:rPr lang="en-US" sz="4400" b="1" dirty="0">
+                <a:solidFill>
+                  <a:srgbClr val="111111"/>
+                </a:solidFill>
+                <a:latin typeface="Avenir Next" pitchFamily="34" charset="0"/>
+                <a:ea typeface="Avenir Next" pitchFamily="34" charset="-122"/>
+                <a:cs typeface="Avenir Next" pitchFamily="34" charset="-120"/>
               </a:rPr>
               <a:t>Let's build four everyday tools</a:t>
             </a:r>
-            <a:endParaRPr lang="en-US" sz="5000" dirty="0"/>
+            <a:endParaRPr lang="en-US" sz="4400" dirty="0"/>
           </a:p>
         </p:txBody>
       </p:sp>
@@ -4963,40 +5270,16 @@
           <a:chExt cx="0" cy="0"/>
         </a:xfrm>
       </p:grpSpPr>
-      <p:pic>
-        <p:nvPicPr>
-          <p:cNvPr id="2" name="Image 0" descr="/Users/batuhangundogdu/Claude Code Workshop/deck/assets/uchicago-footer.png">    </p:cNvPr>
-          <p:cNvPicPr>
-            <a:picLocks noChangeAspect="1"/>
-          </p:cNvPicPr>
-          <p:nvPr/>
-        </p:nvPicPr>
-        <p:blipFill>
-          <a:blip r:embed="rId1"/>
-          <a:stretch>
-            <a:fillRect/>
-          </a:stretch>
-        </p:blipFill>
-        <p:spPr>
-          <a:xfrm>
-            <a:off x="539496" y="6382512"/>
-            <a:ext cx="2843784" cy="475488"/>
-          </a:xfrm>
-          <a:prstGeom prst="rect">
-            <a:avLst/>
-          </a:prstGeom>
-        </p:spPr>
-      </p:pic>
-      <p:sp>
-        <p:nvSpPr>
-          <p:cNvPr id="3" name="Text 0"/>
-          <p:cNvSpPr/>
-          <p:nvPr/>
-        </p:nvSpPr>
-        <p:spPr>
-          <a:xfrm>
-            <a:off x="548640" y="365760"/>
-            <a:ext cx="11091672" cy="1188720"/>
+      <p:sp>
+        <p:nvSpPr>
+          <p:cNvPr id="2" name="Text 0"/>
+          <p:cNvSpPr/>
+          <p:nvPr/>
+        </p:nvSpPr>
+        <p:spPr>
+          <a:xfrm>
+            <a:off x="822960" y="658368"/>
+            <a:ext cx="10543032" cy="274320"/>
           </a:xfrm>
           <a:prstGeom prst="rect">
             <a:avLst/>
@@ -5012,30 +5295,92 @@
               <a:buNone/>
             </a:pPr>
             <a:r>
-              <a:rPr lang="en-US" sz="5000" b="1" dirty="0">
-                <a:solidFill>
-                  <a:srgbClr val="000000"/>
-                </a:solidFill>
-                <a:latin typeface="Calibri" pitchFamily="34" charset="0"/>
-                <a:ea typeface="Calibri" pitchFamily="34" charset="-122"/>
-                <a:cs typeface="Calibri" pitchFamily="34" charset="-120"/>
+              <a:rPr lang="en-US" sz="1200" b="1" spc="250" kern="0" dirty="0">
+                <a:solidFill>
+                  <a:srgbClr val="9A9A9A"/>
+                </a:solidFill>
+                <a:latin typeface="Avenir Next" pitchFamily="34" charset="0"/>
+                <a:ea typeface="Avenir Next" pitchFamily="34" charset="-122"/>
+                <a:cs typeface="Avenir Next" pitchFamily="34" charset="-120"/>
+              </a:rPr>
+              <a:t>THE PLAN</a:t>
+            </a:r>
+            <a:endParaRPr lang="en-US" sz="1200" dirty="0"/>
+          </a:p>
+        </p:txBody>
+      </p:sp>
+      <p:sp>
+        <p:nvSpPr>
+          <p:cNvPr id="3" name="Shape 1"/>
+          <p:cNvSpPr/>
+          <p:nvPr/>
+        </p:nvSpPr>
+        <p:spPr>
+          <a:xfrm>
+            <a:off x="822960" y="969264"/>
+            <a:ext cx="566928" cy="41148"/>
+          </a:xfrm>
+          <a:prstGeom prst="rect">
+            <a:avLst/>
+          </a:prstGeom>
+          <a:solidFill>
+            <a:srgbClr val="2E7A72"/>
+          </a:solidFill>
+          <a:ln/>
+        </p:spPr>
+      </p:sp>
+      <p:sp>
+        <p:nvSpPr>
+          <p:cNvPr id="4" name="Text 2"/>
+          <p:cNvSpPr/>
+          <p:nvPr/>
+        </p:nvSpPr>
+        <p:spPr>
+          <a:xfrm>
+            <a:off x="822960" y="1161288"/>
+            <a:ext cx="10543032" cy="1188720"/>
+          </a:xfrm>
+          <a:prstGeom prst="rect">
+            <a:avLst/>
+          </a:prstGeom>
+          <a:noFill/>
+          <a:ln/>
+        </p:spPr>
+        <p:txBody>
+          <a:bodyPr wrap="square" lIns="0" tIns="0" rIns="0" bIns="0" rtlCol="0" anchor="t"/>
+          <a:lstStyle/>
+          <a:p>
+            <a:pPr algn="l" indent="0" marL="0">
+              <a:lnSpc>
+                <a:spcPct val="98000"/>
+              </a:lnSpc>
+              <a:buNone/>
+            </a:pPr>
+            <a:r>
+              <a:rPr lang="en-US" sz="4000" b="1" dirty="0">
+                <a:solidFill>
+                  <a:srgbClr val="111111"/>
+                </a:solidFill>
+                <a:latin typeface="Avenir Next" pitchFamily="34" charset="0"/>
+                <a:ea typeface="Avenir Next" pitchFamily="34" charset="-122"/>
+                <a:cs typeface="Avenir Next" pitchFamily="34" charset="-120"/>
               </a:rPr>
               <a:t>Four tools, built live, in front of you</a:t>
             </a:r>
-            <a:endParaRPr lang="en-US" sz="5000" dirty="0"/>
-          </a:p>
-        </p:txBody>
-      </p:sp>
-      <p:sp>
-        <p:nvSpPr>
-          <p:cNvPr id="4" name="Text 1"/>
-          <p:cNvSpPr/>
-          <p:nvPr/>
-        </p:nvSpPr>
-        <p:spPr>
-          <a:xfrm>
-            <a:off x="548640" y="1920240"/>
-            <a:ext cx="11091672" cy="4297680"/>
+            <a:endParaRPr lang="en-US" sz="4000" dirty="0"/>
+          </a:p>
+        </p:txBody>
+      </p:sp>
+      <p:sp>
+        <p:nvSpPr>
+          <p:cNvPr id="5" name="Text 3"/>
+          <p:cNvSpPr/>
+          <p:nvPr/>
+        </p:nvSpPr>
+        <p:spPr>
+          <a:xfrm>
+            <a:off x="822960" y="2441448"/>
+            <a:ext cx="10543032" cy="3959352"/>
           </a:xfrm>
           <a:prstGeom prst="rect">
             <a:avLst/>
@@ -5049,129 +5394,129 @@
           <a:p>
             <a:pPr algn="l" indent="0" marL="0">
               <a:lnSpc>
-                <a:spcPct val="110000"/>
+                <a:spcPct val="115000"/>
               </a:lnSpc>
               <a:spcAft>
-                <a:spcPts val="1800"/>
+                <a:spcPts val="1600"/>
               </a:spcAft>
               <a:buNone/>
             </a:pPr>
             <a:r>
-              <a:rPr lang="en-US" sz="2800" dirty="0">
-                <a:solidFill>
-                  <a:srgbClr val="000000"/>
-                </a:solidFill>
-                <a:latin typeface="Calibri" pitchFamily="34" charset="0"/>
-                <a:ea typeface="Calibri" pitchFamily="34" charset="-122"/>
-                <a:cs typeface="Calibri" pitchFamily="34" charset="-120"/>
+              <a:rPr lang="en-US" sz="2000" dirty="0">
+                <a:solidFill>
+                  <a:srgbClr val="111111"/>
+                </a:solidFill>
+                <a:latin typeface="Avenir Next" pitchFamily="34" charset="0"/>
+                <a:ea typeface="Avenir Next" pitchFamily="34" charset="-122"/>
+                <a:cs typeface="Avenir Next" pitchFamily="34" charset="-120"/>
               </a:rPr>
               <a:t>1 · A budget controller - track money, see a chart.</a:t>
             </a:r>
-            <a:endParaRPr lang="en-US" sz="2800" dirty="0"/>
+            <a:endParaRPr lang="en-US" sz="2000" dirty="0"/>
           </a:p>
           <a:p>
             <a:pPr algn="l" indent="0" marL="0">
               <a:lnSpc>
-                <a:spcPct val="110000"/>
+                <a:spcPct val="115000"/>
               </a:lnSpc>
               <a:spcAft>
-                <a:spcPts val="1800"/>
+                <a:spcPts val="1600"/>
               </a:spcAft>
               <a:buNone/>
             </a:pPr>
             <a:r>
-              <a:rPr lang="en-US" sz="2800" dirty="0">
-                <a:solidFill>
-                  <a:srgbClr val="000000"/>
-                </a:solidFill>
-                <a:latin typeface="Calibri" pitchFamily="34" charset="0"/>
-                <a:ea typeface="Calibri" pitchFamily="34" charset="-122"/>
-                <a:cs typeface="Calibri" pitchFamily="34" charset="-120"/>
+              <a:rPr lang="en-US" sz="2000" dirty="0">
+                <a:solidFill>
+                  <a:srgbClr val="111111"/>
+                </a:solidFill>
+                <a:latin typeface="Avenir Next" pitchFamily="34" charset="0"/>
+                <a:ea typeface="Avenir Next" pitchFamily="34" charset="-122"/>
+                <a:cs typeface="Avenir Next" pitchFamily="34" charset="-120"/>
               </a:rPr>
               <a:t>2 · A research paper tracker - what to read, what's done.</a:t>
             </a:r>
-            <a:endParaRPr lang="en-US" sz="2800" dirty="0"/>
+            <a:endParaRPr lang="en-US" sz="2000" dirty="0"/>
           </a:p>
           <a:p>
             <a:pPr algn="l" indent="0" marL="0">
               <a:lnSpc>
-                <a:spcPct val="110000"/>
+                <a:spcPct val="115000"/>
               </a:lnSpc>
               <a:spcAft>
-                <a:spcPts val="1800"/>
+                <a:spcPts val="1600"/>
               </a:spcAft>
               <a:buNone/>
             </a:pPr>
             <a:r>
-              <a:rPr lang="en-US" sz="2800" dirty="0">
-                <a:solidFill>
-                  <a:srgbClr val="000000"/>
-                </a:solidFill>
-                <a:latin typeface="Calibri" pitchFamily="34" charset="0"/>
-                <a:ea typeface="Calibri" pitchFamily="34" charset="-122"/>
-                <a:cs typeface="Calibri" pitchFamily="34" charset="-120"/>
+              <a:rPr lang="en-US" sz="2000" dirty="0">
+                <a:solidFill>
+                  <a:srgbClr val="111111"/>
+                </a:solidFill>
+                <a:latin typeface="Avenir Next" pitchFamily="34" charset="0"/>
+                <a:ea typeface="Avenir Next" pitchFamily="34" charset="-122"/>
+                <a:cs typeface="Avenir Next" pitchFamily="34" charset="-120"/>
               </a:rPr>
               <a:t>3 · A daily dashboard - todos, reminders, nudges.</a:t>
             </a:r>
-            <a:endParaRPr lang="en-US" sz="2800" dirty="0"/>
+            <a:endParaRPr lang="en-US" sz="2000" dirty="0"/>
           </a:p>
           <a:p>
             <a:pPr algn="l" indent="0" marL="0">
               <a:lnSpc>
-                <a:spcPct val="110000"/>
+                <a:spcPct val="115000"/>
               </a:lnSpc>
               <a:spcAft>
-                <a:spcPts val="1800"/>
+                <a:spcPts val="1600"/>
               </a:spcAft>
               <a:buNone/>
             </a:pPr>
             <a:r>
-              <a:rPr lang="en-US" sz="2800" dirty="0">
-                <a:solidFill>
-                  <a:srgbClr val="000000"/>
-                </a:solidFill>
-                <a:latin typeface="Calibri" pitchFamily="34" charset="0"/>
-                <a:ea typeface="Calibri" pitchFamily="34" charset="-122"/>
-                <a:cs typeface="Calibri" pitchFamily="34" charset="-120"/>
+              <a:rPr lang="en-US" sz="2000" dirty="0">
+                <a:solidFill>
+                  <a:srgbClr val="111111"/>
+                </a:solidFill>
+                <a:latin typeface="Avenir Next" pitchFamily="34" charset="0"/>
+                <a:ea typeface="Avenir Next" pitchFamily="34" charset="-122"/>
+                <a:cs typeface="Avenir Next" pitchFamily="34" charset="-120"/>
               </a:rPr>
               <a:t>4 · A teaching assistant - turn a topic into a quiz.</a:t>
             </a:r>
-            <a:endParaRPr lang="en-US" sz="2800" dirty="0"/>
+            <a:endParaRPr lang="en-US" sz="2000" dirty="0"/>
           </a:p>
           <a:p>
             <a:pPr algn="l" indent="0" marL="0">
               <a:lnSpc>
-                <a:spcPct val="110000"/>
+                <a:spcPct val="115000"/>
               </a:lnSpc>
               <a:spcAft>
-                <a:spcPts val="1800"/>
+                <a:spcPts val="1600"/>
               </a:spcAft>
               <a:buNone/>
             </a:pPr>
-            <a:endParaRPr lang="en-US" sz="2800" dirty="0"/>
+            <a:endParaRPr lang="en-US" sz="2000" dirty="0"/>
           </a:p>
           <a:p>
             <a:pPr algn="l" indent="0" marL="0">
               <a:lnSpc>
-                <a:spcPct val="110000"/>
+                <a:spcPct val="115000"/>
               </a:lnSpc>
               <a:spcAft>
-                <a:spcPts val="1800"/>
+                <a:spcPts val="1600"/>
               </a:spcAft>
               <a:buNone/>
             </a:pPr>
             <a:r>
-              <a:rPr lang="en-US" sz="2800" dirty="0">
-                <a:solidFill>
-                  <a:srgbClr val="00B050"/>
-                </a:solidFill>
-                <a:latin typeface="Calibri" pitchFamily="34" charset="0"/>
-                <a:ea typeface="Calibri" pitchFamily="34" charset="-122"/>
-                <a:cs typeface="Calibri" pitchFamily="34" charset="-120"/>
+              <a:rPr lang="en-US" sz="2000" dirty="0">
+                <a:solidFill>
+                  <a:srgbClr val="2E7A72"/>
+                </a:solidFill>
+                <a:latin typeface="Avenir Next" pitchFamily="34" charset="0"/>
+                <a:ea typeface="Avenir Next" pitchFamily="34" charset="-122"/>
+                <a:cs typeface="Avenir Next" pitchFamily="34" charset="-120"/>
               </a:rPr>
               <a:t>Watch for the moment I change the look - just by asking.</a:t>
             </a:r>
-            <a:endParaRPr lang="en-US" sz="2800" dirty="0"/>
+            <a:endParaRPr lang="en-US" sz="2000" dirty="0"/>
           </a:p>
         </p:txBody>
       </p:sp>
@@ -5200,40 +5545,16 @@
           <a:chExt cx="0" cy="0"/>
         </a:xfrm>
       </p:grpSpPr>
-      <p:pic>
-        <p:nvPicPr>
-          <p:cNvPr id="2" name="Image 0" descr="/Users/batuhangundogdu/Claude Code Workshop/deck/assets/uchicago-footer.png">    </p:cNvPr>
-          <p:cNvPicPr>
-            <a:picLocks noChangeAspect="1"/>
-          </p:cNvPicPr>
-          <p:nvPr/>
-        </p:nvPicPr>
-        <p:blipFill>
-          <a:blip r:embed="rId1"/>
-          <a:stretch>
-            <a:fillRect/>
-          </a:stretch>
-        </p:blipFill>
-        <p:spPr>
-          <a:xfrm>
-            <a:off x="539496" y="6382512"/>
-            <a:ext cx="2843784" cy="475488"/>
-          </a:xfrm>
-          <a:prstGeom prst="rect">
-            <a:avLst/>
-          </a:prstGeom>
-        </p:spPr>
-      </p:pic>
-      <p:sp>
-        <p:nvSpPr>
-          <p:cNvPr id="3" name="Text 0"/>
-          <p:cNvSpPr/>
-          <p:nvPr/>
-        </p:nvSpPr>
-        <p:spPr>
-          <a:xfrm>
-            <a:off x="548640" y="2468880"/>
-            <a:ext cx="11091672" cy="457200"/>
+      <p:sp>
+        <p:nvSpPr>
+          <p:cNvPr id="2" name="Text 0"/>
+          <p:cNvSpPr/>
+          <p:nvPr/>
+        </p:nvSpPr>
+        <p:spPr>
+          <a:xfrm>
+            <a:off x="822960" y="2514600"/>
+            <a:ext cx="10543032" cy="365760"/>
           </a:xfrm>
           <a:prstGeom prst="rect">
             <a:avLst/>
@@ -5249,30 +5570,50 @@
               <a:buNone/>
             </a:pPr>
             <a:r>
-              <a:rPr lang="en-US" sz="2400" spc="200" kern="0" dirty="0">
-                <a:solidFill>
-                  <a:srgbClr val="800000"/>
-                </a:solidFill>
-                <a:latin typeface="Calibri" pitchFamily="34" charset="0"/>
-                <a:ea typeface="Calibri" pitchFamily="34" charset="-122"/>
-                <a:cs typeface="Calibri" pitchFamily="34" charset="-120"/>
+              <a:rPr lang="en-US" sz="1500" b="1" spc="300" kern="0" dirty="0">
+                <a:solidFill>
+                  <a:srgbClr val="2E7A72"/>
+                </a:solidFill>
+                <a:latin typeface="Avenir Next" pitchFamily="34" charset="0"/>
+                <a:ea typeface="Avenir Next" pitchFamily="34" charset="-122"/>
+                <a:cs typeface="Avenir Next" pitchFamily="34" charset="-120"/>
               </a:rPr>
               <a:t>DEMO 1</a:t>
             </a:r>
-            <a:endParaRPr lang="en-US" sz="2400" dirty="0"/>
-          </a:p>
-        </p:txBody>
-      </p:sp>
-      <p:sp>
-        <p:nvSpPr>
-          <p:cNvPr id="4" name="Text 1"/>
-          <p:cNvSpPr/>
-          <p:nvPr/>
-        </p:nvSpPr>
-        <p:spPr>
-          <a:xfrm>
-            <a:off x="548640" y="2926080"/>
-            <a:ext cx="11091672" cy="1463040"/>
+            <a:endParaRPr lang="en-US" sz="1500" dirty="0"/>
+          </a:p>
+        </p:txBody>
+      </p:sp>
+      <p:sp>
+        <p:nvSpPr>
+          <p:cNvPr id="3" name="Shape 1"/>
+          <p:cNvSpPr/>
+          <p:nvPr/>
+        </p:nvSpPr>
+        <p:spPr>
+          <a:xfrm>
+            <a:off x="822960" y="2926080"/>
+            <a:ext cx="566928" cy="41148"/>
+          </a:xfrm>
+          <a:prstGeom prst="rect">
+            <a:avLst/>
+          </a:prstGeom>
+          <a:solidFill>
+            <a:srgbClr val="2E7A72"/>
+          </a:solidFill>
+          <a:ln/>
+        </p:spPr>
+      </p:sp>
+      <p:sp>
+        <p:nvSpPr>
+          <p:cNvPr id="4" name="Text 2"/>
+          <p:cNvSpPr/>
+          <p:nvPr/>
+        </p:nvSpPr>
+        <p:spPr>
+          <a:xfrm>
+            <a:off x="822960" y="3108960"/>
+            <a:ext cx="10543032" cy="1463040"/>
           </a:xfrm>
           <a:prstGeom prst="rect">
             <a:avLst/>
@@ -5285,20 +5626,23 @@
           <a:lstStyle/>
           <a:p>
             <a:pPr algn="l" indent="0" marL="0">
-              <a:buNone/>
-            </a:pPr>
-            <a:r>
-              <a:rPr lang="en-US" sz="5000" b="1" dirty="0">
-                <a:solidFill>
-                  <a:srgbClr val="000000"/>
-                </a:solidFill>
-                <a:latin typeface="Calibri" pitchFamily="34" charset="0"/>
-                <a:ea typeface="Calibri" pitchFamily="34" charset="-122"/>
-                <a:cs typeface="Calibri" pitchFamily="34" charset="-120"/>
+              <a:lnSpc>
+                <a:spcPct val="98000"/>
+              </a:lnSpc>
+              <a:buNone/>
+            </a:pPr>
+            <a:r>
+              <a:rPr lang="en-US" sz="4400" b="1" dirty="0">
+                <a:solidFill>
+                  <a:srgbClr val="111111"/>
+                </a:solidFill>
+                <a:latin typeface="Avenir Next" pitchFamily="34" charset="0"/>
+                <a:ea typeface="Avenir Next" pitchFamily="34" charset="-122"/>
+                <a:cs typeface="Avenir Next" pitchFamily="34" charset="-120"/>
               </a:rPr>
               <a:t>Budget Controller</a:t>
             </a:r>
-            <a:endParaRPr lang="en-US" sz="5000" dirty="0"/>
+            <a:endParaRPr lang="en-US" sz="4400" dirty="0"/>
           </a:p>
         </p:txBody>
       </p:sp>

</xml_diff>

<commit_message>
Deck: restore title-slide phoenix and switch accent to UChicago maroon
Bring back the faded phoenix bleeding off the right edge of the cover,
and change the single accent from teal to UChicago maroon (#800000) -
rules, micro-label underlines, emphasis lines, section numbers, and the
stat figure all follow.
</commit_message>
<xml_diff>
--- a/deck/workshop.pptx
+++ b/deck/workshop.pptx
@@ -2364,9 +2364,35 @@
           </a:p>
         </p:txBody>
       </p:sp>
-      <p:sp>
-        <p:nvSpPr>
-          <p:cNvPr id="3" name="Text 1"/>
+      <p:pic>
+        <p:nvPicPr>
+          <p:cNvPr id="3" name="Image 0" descr="/Users/batuhangundogdu/Claude Code Workshop/deck/assets/phoenix.png">    </p:cNvPr>
+          <p:cNvPicPr>
+            <a:picLocks noChangeAspect="1"/>
+          </p:cNvPicPr>
+          <p:nvPr/>
+        </p:nvPicPr>
+        <p:blipFill>
+          <a:blip r:embed="rId1">
+            <a:alphaModFix amt="45000"/>
+          </a:blip>
+          <a:stretch>
+            <a:fillRect/>
+          </a:stretch>
+        </p:blipFill>
+        <p:spPr>
+          <a:xfrm>
+            <a:off x="8311896" y="749808"/>
+            <a:ext cx="5769864" cy="5047488"/>
+          </a:xfrm>
+          <a:prstGeom prst="rect">
+            <a:avLst/>
+          </a:prstGeom>
+        </p:spPr>
+      </p:pic>
+      <p:sp>
+        <p:nvSpPr>
+          <p:cNvPr id="4" name="Text 1"/>
           <p:cNvSpPr/>
           <p:nvPr/>
         </p:nvSpPr>
@@ -2408,7 +2434,7 @@
       </p:sp>
       <p:sp>
         <p:nvSpPr>
-          <p:cNvPr id="4" name="Shape 2"/>
+          <p:cNvPr id="5" name="Shape 2"/>
           <p:cNvSpPr/>
           <p:nvPr/>
         </p:nvSpPr>
@@ -2421,14 +2447,14 @@
             <a:avLst/>
           </a:prstGeom>
           <a:solidFill>
-            <a:srgbClr val="2E7A72"/>
+            <a:srgbClr val="800000"/>
           </a:solidFill>
           <a:ln/>
         </p:spPr>
       </p:sp>
       <p:sp>
         <p:nvSpPr>
-          <p:cNvPr id="5" name="Text 3"/>
+          <p:cNvPr id="6" name="Text 3"/>
           <p:cNvSpPr/>
           <p:nvPr/>
         </p:nvSpPr>
@@ -2467,7 +2493,7 @@
       </p:sp>
       <p:sp>
         <p:nvSpPr>
-          <p:cNvPr id="6" name="Text 4"/>
+          <p:cNvPr id="7" name="Text 4"/>
           <p:cNvSpPr/>
           <p:nvPr/>
         </p:nvSpPr>
@@ -2492,7 +2518,7 @@
             <a:r>
               <a:rPr lang="en-US" sz="1400" b="1" spc="200" kern="0" dirty="0">
                 <a:solidFill>
-                  <a:srgbClr val="2E7A72"/>
+                  <a:srgbClr val="800000"/>
                 </a:solidFill>
                 <a:latin typeface="Avenir Next" pitchFamily="34" charset="0"/>
                 <a:ea typeface="Avenir Next" pitchFamily="34" charset="-122"/>
@@ -2556,7 +2582,7 @@
             <a:r>
               <a:rPr lang="en-US" sz="1500" b="1" spc="300" kern="0" dirty="0">
                 <a:solidFill>
-                  <a:srgbClr val="2E7A72"/>
+                  <a:srgbClr val="800000"/>
                 </a:solidFill>
                 <a:latin typeface="Avenir Next" pitchFamily="34" charset="0"/>
                 <a:ea typeface="Avenir Next" pitchFamily="34" charset="-122"/>
@@ -2583,7 +2609,7 @@
             <a:avLst/>
           </a:prstGeom>
           <a:solidFill>
-            <a:srgbClr val="2E7A72"/>
+            <a:srgbClr val="800000"/>
           </a:solidFill>
           <a:ln/>
         </p:spPr>
@@ -2682,7 +2708,7 @@
             <a:r>
               <a:rPr lang="en-US" sz="1500" b="1" spc="300" kern="0" dirty="0">
                 <a:solidFill>
-                  <a:srgbClr val="2E7A72"/>
+                  <a:srgbClr val="800000"/>
                 </a:solidFill>
                 <a:latin typeface="Avenir Next" pitchFamily="34" charset="0"/>
                 <a:ea typeface="Avenir Next" pitchFamily="34" charset="-122"/>
@@ -2709,7 +2735,7 @@
             <a:avLst/>
           </a:prstGeom>
           <a:solidFill>
-            <a:srgbClr val="2E7A72"/>
+            <a:srgbClr val="800000"/>
           </a:solidFill>
           <a:ln/>
         </p:spPr>
@@ -2808,7 +2834,7 @@
             <a:r>
               <a:rPr lang="en-US" sz="1500" b="1" spc="300" kern="0" dirty="0">
                 <a:solidFill>
-                  <a:srgbClr val="2E7A72"/>
+                  <a:srgbClr val="800000"/>
                 </a:solidFill>
                 <a:latin typeface="Avenir Next" pitchFamily="34" charset="0"/>
                 <a:ea typeface="Avenir Next" pitchFamily="34" charset="-122"/>
@@ -2835,7 +2861,7 @@
             <a:avLst/>
           </a:prstGeom>
           <a:solidFill>
-            <a:srgbClr val="2E7A72"/>
+            <a:srgbClr val="800000"/>
           </a:solidFill>
           <a:ln/>
         </p:spPr>
@@ -2961,7 +2987,7 @@
             <a:avLst/>
           </a:prstGeom>
           <a:solidFill>
-            <a:srgbClr val="2E7A72"/>
+            <a:srgbClr val="800000"/>
           </a:solidFill>
           <a:ln/>
         </p:spPr>
@@ -3041,7 +3067,7 @@
             <a:r>
               <a:rPr lang="en-US" sz="2000" dirty="0">
                 <a:solidFill>
-                  <a:srgbClr val="2E7A72"/>
+                  <a:srgbClr val="800000"/>
                 </a:solidFill>
                 <a:latin typeface="Avenir Next" pitchFamily="34" charset="0"/>
                 <a:ea typeface="Avenir Next" pitchFamily="34" charset="-122"/>
@@ -3064,7 +3090,7 @@
             <a:r>
               <a:rPr lang="en-US" sz="2000" dirty="0">
                 <a:solidFill>
-                  <a:srgbClr val="2E7A72"/>
+                  <a:srgbClr val="800000"/>
                 </a:solidFill>
                 <a:latin typeface="Avenir Next" pitchFamily="34" charset="0"/>
                 <a:ea typeface="Avenir Next" pitchFamily="34" charset="-122"/>
@@ -3087,7 +3113,7 @@
             <a:r>
               <a:rPr lang="en-US" sz="2000" dirty="0">
                 <a:solidFill>
-                  <a:srgbClr val="2E7A72"/>
+                  <a:srgbClr val="800000"/>
                 </a:solidFill>
                 <a:latin typeface="Avenir Next" pitchFamily="34" charset="0"/>
                 <a:ea typeface="Avenir Next" pitchFamily="34" charset="-122"/>
@@ -3122,7 +3148,7 @@
             <a:r>
               <a:rPr lang="en-US" sz="2000" dirty="0">
                 <a:solidFill>
-                  <a:srgbClr val="2E7A72"/>
+                  <a:srgbClr val="800000"/>
                 </a:solidFill>
                 <a:latin typeface="Avenir Next" pitchFamily="34" charset="0"/>
                 <a:ea typeface="Avenir Next" pitchFamily="34" charset="-122"/>
@@ -3186,7 +3212,7 @@
             <a:r>
               <a:rPr lang="en-US" sz="1500" b="1" spc="300" kern="0" dirty="0">
                 <a:solidFill>
-                  <a:srgbClr val="2E7A72"/>
+                  <a:srgbClr val="800000"/>
                 </a:solidFill>
                 <a:latin typeface="Avenir Next" pitchFamily="34" charset="0"/>
                 <a:ea typeface="Avenir Next" pitchFamily="34" charset="-122"/>
@@ -3213,7 +3239,7 @@
             <a:avLst/>
           </a:prstGeom>
           <a:solidFill>
-            <a:srgbClr val="2E7A72"/>
+            <a:srgbClr val="800000"/>
           </a:solidFill>
           <a:ln/>
         </p:spPr>
@@ -3339,7 +3365,7 @@
             <a:avLst/>
           </a:prstGeom>
           <a:solidFill>
-            <a:srgbClr val="2E7A72"/>
+            <a:srgbClr val="800000"/>
           </a:solidFill>
           <a:ln/>
         </p:spPr>
@@ -3371,7 +3397,7 @@
             <a:r>
               <a:rPr lang="en-US" sz="13000" b="1" dirty="0">
                 <a:solidFill>
-                  <a:srgbClr val="2E7A72"/>
+                  <a:srgbClr val="800000"/>
                 </a:solidFill>
                 <a:latin typeface="Avenir Next" pitchFamily="34" charset="0"/>
                 <a:ea typeface="Avenir Next" pitchFamily="34" charset="-122"/>
@@ -3504,7 +3530,7 @@
             <a:avLst/>
           </a:prstGeom>
           <a:solidFill>
-            <a:srgbClr val="2E7A72"/>
+            <a:srgbClr val="800000"/>
           </a:solidFill>
           <a:ln/>
         </p:spPr>
@@ -3584,7 +3610,7 @@
             <a:r>
               <a:rPr lang="en-US" sz="2000" dirty="0">
                 <a:solidFill>
-                  <a:srgbClr val="2E7A72"/>
+                  <a:srgbClr val="800000"/>
                 </a:solidFill>
                 <a:latin typeface="Avenir Next" pitchFamily="34" charset="0"/>
                 <a:ea typeface="Avenir Next" pitchFamily="34" charset="-122"/>
@@ -3756,7 +3782,7 @@
             <a:avLst/>
           </a:prstGeom>
           <a:solidFill>
-            <a:srgbClr val="2E7A72"/>
+            <a:srgbClr val="800000"/>
           </a:solidFill>
           <a:ln/>
         </p:spPr>
@@ -3836,7 +3862,7 @@
             <a:r>
               <a:rPr lang="en-US" sz="2000" dirty="0">
                 <a:solidFill>
-                  <a:srgbClr val="2E7A72"/>
+                  <a:srgbClr val="800000"/>
                 </a:solidFill>
                 <a:latin typeface="Avenir Next" pitchFamily="34" charset="0"/>
                 <a:ea typeface="Avenir Next" pitchFamily="34" charset="-122"/>
@@ -3894,7 +3920,7 @@
             <a:r>
               <a:rPr lang="en-US" sz="2000" dirty="0">
                 <a:solidFill>
-                  <a:srgbClr val="2E7A72"/>
+                  <a:srgbClr val="800000"/>
                 </a:solidFill>
                 <a:latin typeface="Avenir Next" pitchFamily="34" charset="0"/>
                 <a:ea typeface="Avenir Next" pitchFamily="34" charset="-122"/>
@@ -3985,7 +4011,7 @@
             <a:avLst/>
           </a:prstGeom>
           <a:solidFill>
-            <a:srgbClr val="2E7A72"/>
+            <a:srgbClr val="800000"/>
           </a:solidFill>
           <a:ln/>
         </p:spPr>
@@ -4100,7 +4126,7 @@
             <a:r>
               <a:rPr lang="en-US" sz="2000" dirty="0">
                 <a:solidFill>
-                  <a:srgbClr val="2E7A72"/>
+                  <a:srgbClr val="800000"/>
                 </a:solidFill>
                 <a:latin typeface="Avenir Next" pitchFamily="34" charset="0"/>
                 <a:ea typeface="Avenir Next" pitchFamily="34" charset="-122"/>
@@ -4123,7 +4149,7 @@
             <a:r>
               <a:rPr lang="en-US" sz="2000" dirty="0">
                 <a:solidFill>
-                  <a:srgbClr val="2E7A72"/>
+                  <a:srgbClr val="800000"/>
                 </a:solidFill>
                 <a:latin typeface="Avenir Next" pitchFamily="34" charset="0"/>
                 <a:ea typeface="Avenir Next" pitchFamily="34" charset="-122"/>
@@ -4210,7 +4236,7 @@
             <a:r>
               <a:rPr lang="en-US" sz="1500" b="1" spc="300" kern="0" dirty="0">
                 <a:solidFill>
-                  <a:srgbClr val="2E7A72"/>
+                  <a:srgbClr val="800000"/>
                 </a:solidFill>
                 <a:latin typeface="Avenir Next" pitchFamily="34" charset="0"/>
                 <a:ea typeface="Avenir Next" pitchFamily="34" charset="-122"/>
@@ -4237,7 +4263,7 @@
             <a:avLst/>
           </a:prstGeom>
           <a:solidFill>
-            <a:srgbClr val="2E7A72"/>
+            <a:srgbClr val="800000"/>
           </a:solidFill>
           <a:ln/>
         </p:spPr>
@@ -4363,7 +4389,7 @@
             <a:avLst/>
           </a:prstGeom>
           <a:solidFill>
-            <a:srgbClr val="2E7A72"/>
+            <a:srgbClr val="800000"/>
           </a:solidFill>
           <a:ln/>
         </p:spPr>
@@ -4443,7 +4469,7 @@
             <a:r>
               <a:rPr lang="en-US" sz="2000" dirty="0">
                 <a:solidFill>
-                  <a:srgbClr val="2E7A72"/>
+                  <a:srgbClr val="800000"/>
                 </a:solidFill>
                 <a:latin typeface="Avenir Next" pitchFamily="34" charset="0"/>
                 <a:ea typeface="Avenir Next" pitchFamily="34" charset="-122"/>
@@ -4489,7 +4515,7 @@
             <a:r>
               <a:rPr lang="en-US" sz="2000" dirty="0">
                 <a:solidFill>
-                  <a:srgbClr val="2E7A72"/>
+                  <a:srgbClr val="800000"/>
                 </a:solidFill>
                 <a:latin typeface="Avenir Next" pitchFamily="34" charset="0"/>
                 <a:ea typeface="Avenir Next" pitchFamily="34" charset="-122"/>
@@ -4615,7 +4641,7 @@
             <a:avLst/>
           </a:prstGeom>
           <a:solidFill>
-            <a:srgbClr val="2E7A72"/>
+            <a:srgbClr val="800000"/>
           </a:solidFill>
           <a:ln/>
         </p:spPr>
@@ -4832,7 +4858,7 @@
             <a:r>
               <a:rPr lang="en-US" sz="2000" dirty="0">
                 <a:solidFill>
-                  <a:srgbClr val="2E7A72"/>
+                  <a:srgbClr val="800000"/>
                 </a:solidFill>
                 <a:latin typeface="Avenir Next" pitchFamily="34" charset="0"/>
                 <a:ea typeface="Avenir Next" pitchFamily="34" charset="-122"/>
@@ -4855,7 +4881,7 @@
             <a:r>
               <a:rPr lang="en-US" sz="2000" dirty="0">
                 <a:solidFill>
-                  <a:srgbClr val="2E7A72"/>
+                  <a:srgbClr val="800000"/>
                 </a:solidFill>
                 <a:latin typeface="Avenir Next" pitchFamily="34" charset="0"/>
                 <a:ea typeface="Avenir Next" pitchFamily="34" charset="-122"/>
@@ -4878,7 +4904,7 @@
             <a:r>
               <a:rPr lang="en-US" sz="2000" dirty="0">
                 <a:solidFill>
-                  <a:srgbClr val="2E7A72"/>
+                  <a:srgbClr val="800000"/>
                 </a:solidFill>
                 <a:latin typeface="Avenir Next" pitchFamily="34" charset="0"/>
                 <a:ea typeface="Avenir Next" pitchFamily="34" charset="-122"/>
@@ -4969,7 +4995,7 @@
             <a:avLst/>
           </a:prstGeom>
           <a:solidFill>
-            <a:srgbClr val="2E7A72"/>
+            <a:srgbClr val="800000"/>
           </a:solidFill>
           <a:ln/>
         </p:spPr>
@@ -5049,7 +5075,7 @@
             <a:r>
               <a:rPr lang="en-US" sz="2000" dirty="0">
                 <a:solidFill>
-                  <a:srgbClr val="2E7A72"/>
+                  <a:srgbClr val="800000"/>
                 </a:solidFill>
                 <a:latin typeface="Avenir Next" pitchFamily="34" charset="0"/>
                 <a:ea typeface="Avenir Next" pitchFamily="34" charset="-122"/>
@@ -5072,7 +5098,7 @@
             <a:r>
               <a:rPr lang="en-US" sz="2000" dirty="0">
                 <a:solidFill>
-                  <a:srgbClr val="2E7A72"/>
+                  <a:srgbClr val="800000"/>
                 </a:solidFill>
                 <a:latin typeface="Avenir Next" pitchFamily="34" charset="0"/>
                 <a:ea typeface="Avenir Next" pitchFamily="34" charset="-122"/>
@@ -5171,7 +5197,7 @@
             <a:r>
               <a:rPr lang="en-US" sz="1500" b="1" spc="300" kern="0" dirty="0">
                 <a:solidFill>
-                  <a:srgbClr val="2E7A72"/>
+                  <a:srgbClr val="800000"/>
                 </a:solidFill>
                 <a:latin typeface="Avenir Next" pitchFamily="34" charset="0"/>
                 <a:ea typeface="Avenir Next" pitchFamily="34" charset="-122"/>
@@ -5198,7 +5224,7 @@
             <a:avLst/>
           </a:prstGeom>
           <a:solidFill>
-            <a:srgbClr val="2E7A72"/>
+            <a:srgbClr val="800000"/>
           </a:solidFill>
           <a:ln/>
         </p:spPr>
@@ -5324,7 +5350,7 @@
             <a:avLst/>
           </a:prstGeom>
           <a:solidFill>
-            <a:srgbClr val="2E7A72"/>
+            <a:srgbClr val="800000"/>
           </a:solidFill>
           <a:ln/>
         </p:spPr>
@@ -5508,7 +5534,7 @@
             <a:r>
               <a:rPr lang="en-US" sz="2000" dirty="0">
                 <a:solidFill>
-                  <a:srgbClr val="2E7A72"/>
+                  <a:srgbClr val="800000"/>
                 </a:solidFill>
                 <a:latin typeface="Avenir Next" pitchFamily="34" charset="0"/>
                 <a:ea typeface="Avenir Next" pitchFamily="34" charset="-122"/>
@@ -5572,7 +5598,7 @@
             <a:r>
               <a:rPr lang="en-US" sz="1500" b="1" spc="300" kern="0" dirty="0">
                 <a:solidFill>
-                  <a:srgbClr val="2E7A72"/>
+                  <a:srgbClr val="800000"/>
                 </a:solidFill>
                 <a:latin typeface="Avenir Next" pitchFamily="34" charset="0"/>
                 <a:ea typeface="Avenir Next" pitchFamily="34" charset="-122"/>
@@ -5599,7 +5625,7 @@
             <a:avLst/>
           </a:prstGeom>
           <a:solidFill>
-            <a:srgbClr val="2E7A72"/>
+            <a:srgbClr val="800000"/>
           </a:solidFill>
           <a:ln/>
         </p:spPr>

</xml_diff>